<commit_message>
Trust template layout: fix Picture 111, remove grid overrides, add footer with date
- config.py: update all TemplateLayout EMU constants to match updated template;
  delete DATE_*, DIVIDER_H, DIVIDER_OFFSET, Grid.HEADER_COLOR (no longer needed)
- pptx_generator.py: rename Picture 15 → Picture 111 (matches template id=112);
  delete 7 now-redundant functions (_apply_grid_layout, _style_section_header,
  _add_section_divider, _update_date, _set_text_padding, _reposition_shape,
  _update_source_url); add _extract_domain + _update_footer (4-run footer with
  hyperlinked domain + date); add phantom shape cleanup (id=107, 108, ZoneTexte 6)
  at slide generation start; add urlparse import, remove MSO_SHAPE/RGBColor
- templates/slide_template.pptx: updated template (positions, RED labels, single
  divider, Picture 111 slot, no standalone date shape)

Co-Authored-By: Claude Sonnet 4.6 <noreply@anthropic.com>
</commit_message>
<xml_diff>
--- a/templates/slide_template.pptx
+++ b/templates/slide_template.pptx
@@ -8,7 +8,7 @@
     <p:notesMasterId r:id="rId3"/>
   </p:notesMasterIdLst>
   <p:sldIdLst>
-    <p:sldId id="21422" r:id="rId2"/>
+    <p:sldId id="21423" r:id="rId2"/>
   </p:sldIdLst>
   <p:sldSz cx="12192000" cy="6858000"/>
   <p:notesSz cx="6807200" cy="9939338"/>
@@ -273,7 +273,7 @@
           <a:p>
             <a:fld id="{C3F50CBD-067C-8D49-95C2-FEDAC8DBCCD5}" type="datetimeFigureOut">
               <a:rPr lang="en-US" smtClean="0"/>
-              <a:t>3/17/26</a:t>
+              <a:t>3/18/26</a:t>
             </a:fld>
             <a:endParaRPr lang="en-US"/>
           </a:p>
@@ -7152,1110 +7152,6 @@
 </file>
 
 <file path=ppt/slideLayouts/slideLayout18.xml><?xml version="1.0" encoding="utf-8"?>
-<p:sldLayout xmlns:a="http://schemas.openxmlformats.org/drawingml/2006/main" xmlns:r="http://schemas.openxmlformats.org/officeDocument/2006/relationships" xmlns:p="http://schemas.openxmlformats.org/presentationml/2006/main" matchingName="Title only" type="titleOnly">
-  <p:cSld name="Title only">
-    <p:spTree>
-      <p:nvGrpSpPr>
-        <p:cNvPr id="1" name="Shape 36"/>
-        <p:cNvGrpSpPr/>
-        <p:nvPr/>
-      </p:nvGrpSpPr>
-      <p:grpSpPr>
-        <a:xfrm>
-          <a:off x="0" y="0"/>
-          <a:ext cx="0" cy="0"/>
-          <a:chOff x="0" y="0"/>
-          <a:chExt cx="0" cy="0"/>
-        </a:xfrm>
-      </p:grpSpPr>
-      <p:sp>
-        <p:nvSpPr>
-          <p:cNvPr id="37" name="Google Shape;37;p6"/>
-          <p:cNvSpPr txBox="1">
-            <a:spLocks noGrp="1"/>
-          </p:cNvSpPr>
-          <p:nvPr>
-            <p:ph type="title"/>
-          </p:nvPr>
-        </p:nvSpPr>
-        <p:spPr>
-          <a:xfrm>
-            <a:off x="404400" y="421767"/>
-            <a:ext cx="11360800" cy="852800"/>
-          </a:xfrm>
-          <a:prstGeom prst="rect">
-            <a:avLst/>
-          </a:prstGeom>
-        </p:spPr>
-        <p:txBody>
-          <a:bodyPr spcFirstLastPara="1" wrap="square" lIns="91425" tIns="91425" rIns="91425" bIns="91425" anchor="t" anchorCtr="0">
-            <a:noAutofit/>
-          </a:bodyPr>
-          <a:lstStyle>
-            <a:lvl1pPr lvl="0">
-              <a:spcBef>
-                <a:spcPts val="0"/>
-              </a:spcBef>
-              <a:spcAft>
-                <a:spcPts val="0"/>
-              </a:spcAft>
-              <a:buSzPts val="3000"/>
-              <a:buNone/>
-              <a:defRPr/>
-            </a:lvl1pPr>
-            <a:lvl2pPr lvl="1">
-              <a:spcBef>
-                <a:spcPts val="0"/>
-              </a:spcBef>
-              <a:spcAft>
-                <a:spcPts val="0"/>
-              </a:spcAft>
-              <a:buSzPts val="3000"/>
-              <a:buNone/>
-              <a:defRPr/>
-            </a:lvl2pPr>
-            <a:lvl3pPr lvl="2">
-              <a:spcBef>
-                <a:spcPts val="0"/>
-              </a:spcBef>
-              <a:spcAft>
-                <a:spcPts val="0"/>
-              </a:spcAft>
-              <a:buSzPts val="3000"/>
-              <a:buNone/>
-              <a:defRPr/>
-            </a:lvl3pPr>
-            <a:lvl4pPr lvl="3">
-              <a:spcBef>
-                <a:spcPts val="0"/>
-              </a:spcBef>
-              <a:spcAft>
-                <a:spcPts val="0"/>
-              </a:spcAft>
-              <a:buSzPts val="3000"/>
-              <a:buNone/>
-              <a:defRPr/>
-            </a:lvl4pPr>
-            <a:lvl5pPr lvl="4">
-              <a:spcBef>
-                <a:spcPts val="0"/>
-              </a:spcBef>
-              <a:spcAft>
-                <a:spcPts val="0"/>
-              </a:spcAft>
-              <a:buSzPts val="3000"/>
-              <a:buNone/>
-              <a:defRPr/>
-            </a:lvl5pPr>
-            <a:lvl6pPr lvl="5">
-              <a:spcBef>
-                <a:spcPts val="0"/>
-              </a:spcBef>
-              <a:spcAft>
-                <a:spcPts val="0"/>
-              </a:spcAft>
-              <a:buSzPts val="3000"/>
-              <a:buNone/>
-              <a:defRPr/>
-            </a:lvl6pPr>
-            <a:lvl7pPr lvl="6">
-              <a:spcBef>
-                <a:spcPts val="0"/>
-              </a:spcBef>
-              <a:spcAft>
-                <a:spcPts val="0"/>
-              </a:spcAft>
-              <a:buSzPts val="3000"/>
-              <a:buNone/>
-              <a:defRPr/>
-            </a:lvl7pPr>
-            <a:lvl8pPr lvl="7">
-              <a:spcBef>
-                <a:spcPts val="0"/>
-              </a:spcBef>
-              <a:spcAft>
-                <a:spcPts val="0"/>
-              </a:spcAft>
-              <a:buSzPts val="3000"/>
-              <a:buNone/>
-              <a:defRPr/>
-            </a:lvl8pPr>
-            <a:lvl9pPr lvl="8">
-              <a:spcBef>
-                <a:spcPts val="0"/>
-              </a:spcBef>
-              <a:spcAft>
-                <a:spcPts val="0"/>
-              </a:spcAft>
-              <a:buSzPts val="3000"/>
-              <a:buNone/>
-              <a:defRPr/>
-            </a:lvl9pPr>
-          </a:lstStyle>
-          <a:p>
-            <a:r>
-              <a:rPr lang="fr-FR"/>
-              <a:t>Modifiez le style du titre</a:t>
-            </a:r>
-            <a:endParaRPr/>
-          </a:p>
-        </p:txBody>
-      </p:sp>
-      <p:sp>
-        <p:nvSpPr>
-          <p:cNvPr id="38" name="Google Shape;38;p6"/>
-          <p:cNvSpPr txBox="1">
-            <a:spLocks noGrp="1"/>
-          </p:cNvSpPr>
-          <p:nvPr>
-            <p:ph type="sldNum" idx="12"/>
-          </p:nvPr>
-        </p:nvSpPr>
-        <p:spPr>
-          <a:xfrm>
-            <a:off x="11330666" y="6251679"/>
-            <a:ext cx="731600" cy="524800"/>
-          </a:xfrm>
-          <a:prstGeom prst="rect">
-            <a:avLst/>
-          </a:prstGeom>
-        </p:spPr>
-        <p:txBody>
-          <a:bodyPr spcFirstLastPara="1" wrap="square" lIns="91425" tIns="91425" rIns="91425" bIns="91425" anchor="ctr" anchorCtr="0">
-            <a:noAutofit/>
-          </a:bodyPr>
-          <a:lstStyle>
-            <a:lvl1pPr lvl="0">
-              <a:buNone/>
-              <a:defRPr/>
-            </a:lvl1pPr>
-            <a:lvl2pPr lvl="1">
-              <a:buNone/>
-              <a:defRPr/>
-            </a:lvl2pPr>
-            <a:lvl3pPr lvl="2">
-              <a:buNone/>
-              <a:defRPr/>
-            </a:lvl3pPr>
-            <a:lvl4pPr lvl="3">
-              <a:buNone/>
-              <a:defRPr/>
-            </a:lvl4pPr>
-            <a:lvl5pPr lvl="4">
-              <a:buNone/>
-              <a:defRPr/>
-            </a:lvl5pPr>
-            <a:lvl6pPr lvl="5">
-              <a:buNone/>
-              <a:defRPr/>
-            </a:lvl6pPr>
-            <a:lvl7pPr lvl="6">
-              <a:buNone/>
-              <a:defRPr/>
-            </a:lvl7pPr>
-            <a:lvl8pPr lvl="7">
-              <a:buNone/>
-              <a:defRPr/>
-            </a:lvl8pPr>
-            <a:lvl9pPr lvl="8">
-              <a:buNone/>
-              <a:defRPr/>
-            </a:lvl9pPr>
-          </a:lstStyle>
-          <a:p>
-            <a:fld id="{1B5E06C8-4CCE-445E-BB25-07CA23AD9097}" type="slidenum">
-              <a:rPr lang="ja-JP" altLang="en-US" smtClean="0"/>
-              <a:pPr/>
-              <a:t>‹#›</a:t>
-            </a:fld>
-            <a:endParaRPr lang="ja-JP" altLang="en-US"/>
-          </a:p>
-        </p:txBody>
-      </p:sp>
-    </p:spTree>
-    <p:extLst>
-      <p:ext uri="{BB962C8B-B14F-4D97-AF65-F5344CB8AC3E}">
-        <p14:creationId xmlns:p14="http://schemas.microsoft.com/office/powerpoint/2010/main" val="202606714"/>
-      </p:ext>
-    </p:extLst>
-  </p:cSld>
-  <p:clrMapOvr>
-    <a:masterClrMapping/>
-  </p:clrMapOvr>
-  <p:hf sldNum="0" hdr="0" ftr="0"/>
-</p:sldLayout>
-</file>
-
-<file path=ppt/slideLayouts/slideLayout19.xml><?xml version="1.0" encoding="utf-8"?>
-<p:sldLayout xmlns:a="http://schemas.openxmlformats.org/drawingml/2006/main" xmlns:r="http://schemas.openxmlformats.org/officeDocument/2006/relationships" xmlns:p="http://schemas.openxmlformats.org/presentationml/2006/main" userDrawn="1">
-  <p:cSld name="3_Title Only">
-    <p:spTree>
-      <p:nvGrpSpPr>
-        <p:cNvPr id="1" name=""/>
-        <p:cNvGrpSpPr/>
-        <p:nvPr/>
-      </p:nvGrpSpPr>
-      <p:grpSpPr>
-        <a:xfrm>
-          <a:off x="0" y="0"/>
-          <a:ext cx="0" cy="0"/>
-          <a:chOff x="0" y="0"/>
-          <a:chExt cx="0" cy="0"/>
-        </a:xfrm>
-      </p:grpSpPr>
-      <p:sp>
-        <p:nvSpPr>
-          <p:cNvPr id="11" name="Rectangle 3"/>
-          <p:cNvSpPr>
-            <a:spLocks noGrp="1" noChangeArrowheads="1"/>
-          </p:cNvSpPr>
-          <p:nvPr>
-            <p:ph type="title"/>
-          </p:nvPr>
-        </p:nvSpPr>
-        <p:spPr bwMode="auto">
-          <a:xfrm>
-            <a:off x="125413" y="138113"/>
-            <a:ext cx="11000856" cy="406168"/>
-          </a:xfrm>
-          <a:prstGeom prst="rect">
-            <a:avLst/>
-          </a:prstGeom>
-          <a:noFill/>
-          <a:ln>
-            <a:noFill/>
-          </a:ln>
-          <a:effectLst/>
-        </p:spPr>
-        <p:txBody>
-          <a:bodyPr/>
-          <a:lstStyle>
-            <a:lvl1pPr>
-              <a:defRPr sz="1800" b="0">
-                <a:solidFill>
-                  <a:schemeClr val="tx1"/>
-                </a:solidFill>
-              </a:defRPr>
-            </a:lvl1pPr>
-          </a:lstStyle>
-          <a:p>
-            <a:pPr lvl="0"/>
-            <a:r>
-              <a:rPr lang="ja-JP" altLang="en-US"/>
-              <a:t>マスター タイトルの書式設定</a:t>
-            </a:r>
-            <a:endParaRPr lang="en-GB" dirty="0"/>
-          </a:p>
-        </p:txBody>
-      </p:sp>
-      <p:pic>
-        <p:nvPicPr>
-          <p:cNvPr id="2" name="Picture 2" descr="A red and black logo&#10;&#10;Description automatically generated">
-            <a:extLst>
-              <a:ext uri="{FF2B5EF4-FFF2-40B4-BE49-F238E27FC236}">
-                <a16:creationId xmlns:a16="http://schemas.microsoft.com/office/drawing/2014/main" id="{400EC8D7-6DC9-1605-F404-BE42B7E8F988}"/>
-              </a:ext>
-            </a:extLst>
-          </p:cNvPr>
-          <p:cNvPicPr>
-            <a:picLocks noChangeAspect="1"/>
-          </p:cNvPicPr>
-          <p:nvPr userDrawn="1"/>
-        </p:nvPicPr>
-        <p:blipFill>
-          <a:blip r:embed="rId2" cstate="screen">
-            <a:extLst>
-              <a:ext uri="{28A0092B-C50C-407E-A947-70E740481C1C}">
-                <a14:useLocalDpi xmlns:a14="http://schemas.microsoft.com/office/drawing/2010/main"/>
-              </a:ext>
-            </a:extLst>
-          </a:blip>
-          <a:stretch>
-            <a:fillRect/>
-          </a:stretch>
-        </p:blipFill>
-        <p:spPr>
-          <a:xfrm>
-            <a:off x="11182076" y="194549"/>
-            <a:ext cx="872930" cy="263759"/>
-          </a:xfrm>
-          <a:prstGeom prst="rect">
-            <a:avLst/>
-          </a:prstGeom>
-        </p:spPr>
-      </p:pic>
-      <p:sp>
-        <p:nvSpPr>
-          <p:cNvPr id="12" name="Text Placeholder 11">
-            <a:extLst>
-              <a:ext uri="{FF2B5EF4-FFF2-40B4-BE49-F238E27FC236}">
-                <a16:creationId xmlns:a16="http://schemas.microsoft.com/office/drawing/2014/main" id="{63AC8FD2-8097-2400-BA1E-5C2A5A1A5C2A}"/>
-              </a:ext>
-            </a:extLst>
-          </p:cNvPr>
-          <p:cNvSpPr>
-            <a:spLocks noGrp="1"/>
-          </p:cNvSpPr>
-          <p:nvPr>
-            <p:ph type="body" sz="quarter" idx="11" hasCustomPrompt="1"/>
-          </p:nvPr>
-        </p:nvSpPr>
-        <p:spPr>
-          <a:xfrm>
-            <a:off x="11046932" y="0"/>
-            <a:ext cx="1019656" cy="190053"/>
-          </a:xfrm>
-          <a:prstGeom prst="rect">
-            <a:avLst/>
-          </a:prstGeom>
-        </p:spPr>
-        <p:txBody>
-          <a:bodyPr/>
-          <a:lstStyle>
-            <a:lvl1pPr marL="0" indent="0" algn="r">
-              <a:buNone/>
-              <a:defRPr sz="800"/>
-            </a:lvl1pPr>
-            <a:lvl2pPr>
-              <a:defRPr sz="2000"/>
-            </a:lvl2pPr>
-            <a:lvl3pPr>
-              <a:defRPr sz="2000"/>
-            </a:lvl3pPr>
-            <a:lvl4pPr>
-              <a:defRPr sz="2000"/>
-            </a:lvl4pPr>
-            <a:lvl5pPr>
-              <a:defRPr sz="2000"/>
-            </a:lvl5pPr>
-          </a:lstStyle>
-          <a:p>
-            <a:pPr lvl="0"/>
-            <a:r>
-              <a:rPr lang="en-US" dirty="0"/>
-              <a:t>date/month/year</a:t>
-            </a:r>
-            <a:endParaRPr lang="en-FI" dirty="0"/>
-          </a:p>
-        </p:txBody>
-      </p:sp>
-    </p:spTree>
-    <p:extLst>
-      <p:ext uri="{BB962C8B-B14F-4D97-AF65-F5344CB8AC3E}">
-        <p14:creationId xmlns:p14="http://schemas.microsoft.com/office/powerpoint/2010/main" val="766932496"/>
-      </p:ext>
-    </p:extLst>
-  </p:cSld>
-  <p:clrMapOvr>
-    <a:masterClrMapping/>
-  </p:clrMapOvr>
-</p:sldLayout>
-</file>
-
-<file path=ppt/slideLayouts/slideLayout2.xml><?xml version="1.0" encoding="utf-8"?>
-<p:sldLayout xmlns:a="http://schemas.openxmlformats.org/drawingml/2006/main" xmlns:r="http://schemas.openxmlformats.org/officeDocument/2006/relationships" xmlns:p="http://schemas.openxmlformats.org/presentationml/2006/main" preserve="1">
-  <p:cSld name="1_Disposition personnalisée">
-    <p:spTree>
-      <p:nvGrpSpPr>
-        <p:cNvPr id="1" name=""/>
-        <p:cNvGrpSpPr/>
-        <p:nvPr/>
-      </p:nvGrpSpPr>
-      <p:grpSpPr>
-        <a:xfrm>
-          <a:off x="0" y="0"/>
-          <a:ext cx="0" cy="0"/>
-          <a:chOff x="0" y="0"/>
-          <a:chExt cx="0" cy="0"/>
-        </a:xfrm>
-      </p:grpSpPr>
-      <p:sp>
-        <p:nvSpPr>
-          <p:cNvPr id="9" name="Rectangle 8">
-            <a:extLst>
-              <a:ext uri="{FF2B5EF4-FFF2-40B4-BE49-F238E27FC236}">
-                <a16:creationId xmlns:a16="http://schemas.microsoft.com/office/drawing/2014/main" id="{740FA9FB-A6BA-AD43-B17A-3E6D7C1DCDD4}"/>
-              </a:ext>
-            </a:extLst>
-          </p:cNvPr>
-          <p:cNvSpPr/>
-          <p:nvPr/>
-        </p:nvSpPr>
-        <p:spPr bwMode="auto">
-          <a:xfrm>
-            <a:off x="609599" y="620155"/>
-            <a:ext cx="10991850" cy="5726857"/>
-          </a:xfrm>
-          <a:prstGeom prst="rect">
-            <a:avLst/>
-          </a:prstGeom>
-          <a:solidFill>
-            <a:srgbClr val="F8F6F3">
-              <a:alpha val="51765"/>
-            </a:srgbClr>
-          </a:solidFill>
-          <a:ln>
-            <a:noFill/>
-          </a:ln>
-        </p:spPr>
-        <p:txBody>
-          <a:bodyPr vert="horz" wrap="square" lIns="49530" tIns="24765" rIns="49530" bIns="24765" numCol="1" rtlCol="0" anchor="t" anchorCtr="0" compatLnSpc="1">
-            <a:prstTxWarp prst="textNoShape">
-              <a:avLst/>
-            </a:prstTxWarp>
-          </a:bodyPr>
-          <a:lstStyle/>
-          <a:p>
-            <a:pPr algn="ctr"/>
-            <a:endParaRPr lang="fr-FR" sz="858" dirty="0"/>
-          </a:p>
-        </p:txBody>
-      </p:sp>
-      <p:sp>
-        <p:nvSpPr>
-          <p:cNvPr id="6" name="Espace réservé du texte 5">
-            <a:extLst>
-              <a:ext uri="{FF2B5EF4-FFF2-40B4-BE49-F238E27FC236}">
-                <a16:creationId xmlns:a16="http://schemas.microsoft.com/office/drawing/2014/main" id="{4287D38D-5798-F546-AAAE-D178455CEE7B}"/>
-              </a:ext>
-            </a:extLst>
-          </p:cNvPr>
-          <p:cNvSpPr>
-            <a:spLocks noGrp="1"/>
-          </p:cNvSpPr>
-          <p:nvPr>
-            <p:ph type="body" sz="quarter" idx="12" hasCustomPrompt="1"/>
-          </p:nvPr>
-        </p:nvSpPr>
-        <p:spPr>
-          <a:xfrm>
-            <a:off x="508000" y="242123"/>
-            <a:ext cx="5172576" cy="386499"/>
-          </a:xfrm>
-          <a:prstGeom prst="rect">
-            <a:avLst/>
-          </a:prstGeom>
-        </p:spPr>
-        <p:txBody>
-          <a:bodyPr/>
-          <a:lstStyle>
-            <a:lvl1pPr>
-              <a:defRPr sz="900" b="1" i="0" cap="all" spc="300" baseline="0">
-                <a:solidFill>
-                  <a:schemeClr val="tx1">
-                    <a:lumMod val="65000"/>
-                    <a:lumOff val="35000"/>
-                  </a:schemeClr>
-                </a:solidFill>
-                <a:latin typeface="Brown" pitchFamily="2" charset="77"/>
-              </a:defRPr>
-            </a:lvl1pPr>
-            <a:lvl2pPr>
-              <a:defRPr sz="900" b="1" spc="300">
-                <a:solidFill>
-                  <a:schemeClr val="tx1">
-                    <a:lumMod val="75000"/>
-                    <a:lumOff val="25000"/>
-                  </a:schemeClr>
-                </a:solidFill>
-              </a:defRPr>
-            </a:lvl2pPr>
-            <a:lvl3pPr>
-              <a:defRPr sz="900" b="1" spc="300">
-                <a:solidFill>
-                  <a:schemeClr val="tx1">
-                    <a:lumMod val="75000"/>
-                    <a:lumOff val="25000"/>
-                  </a:schemeClr>
-                </a:solidFill>
-              </a:defRPr>
-            </a:lvl3pPr>
-            <a:lvl4pPr>
-              <a:defRPr sz="900" b="1" spc="300">
-                <a:solidFill>
-                  <a:schemeClr val="tx1">
-                    <a:lumMod val="75000"/>
-                    <a:lumOff val="25000"/>
-                  </a:schemeClr>
-                </a:solidFill>
-              </a:defRPr>
-            </a:lvl4pPr>
-            <a:lvl5pPr>
-              <a:defRPr sz="900" b="1" spc="300">
-                <a:solidFill>
-                  <a:schemeClr val="tx1">
-                    <a:lumMod val="75000"/>
-                    <a:lumOff val="25000"/>
-                  </a:schemeClr>
-                </a:solidFill>
-              </a:defRPr>
-            </a:lvl5pPr>
-          </a:lstStyle>
-          <a:p>
-            <a:pPr lvl="0"/>
-            <a:r>
-              <a:rPr lang="fr-FR" dirty="0"/>
-              <a:t>BASIC SLIDE COMPOSITION </a:t>
-            </a:r>
-          </a:p>
-        </p:txBody>
-      </p:sp>
-      <p:sp>
-        <p:nvSpPr>
-          <p:cNvPr id="2" name="ZoneTexte 1">
-            <a:extLst>
-              <a:ext uri="{FF2B5EF4-FFF2-40B4-BE49-F238E27FC236}">
-                <a16:creationId xmlns:a16="http://schemas.microsoft.com/office/drawing/2014/main" id="{9E438AA4-7DC6-424C-B339-C11671851E37}"/>
-              </a:ext>
-            </a:extLst>
-          </p:cNvPr>
-          <p:cNvSpPr txBox="1"/>
-          <p:nvPr/>
-        </p:nvSpPr>
-        <p:spPr>
-          <a:xfrm>
-            <a:off x="8986053" y="189092"/>
-            <a:ext cx="2615396" cy="295002"/>
-          </a:xfrm>
-          <a:prstGeom prst="rect">
-            <a:avLst/>
-          </a:prstGeom>
-        </p:spPr>
-        <p:txBody>
-          <a:bodyPr wrap="none" lIns="0" tIns="0" rIns="0" bIns="0" rtlCol="0" anchor="ctr" anchorCtr="0">
-            <a:noAutofit/>
-          </a:bodyPr>
-          <a:lstStyle/>
-          <a:p>
-            <a:pPr algn="r"/>
-            <a:r>
-              <a:rPr lang="fr-FR" sz="800" b="0" spc="300" dirty="0">
-                <a:solidFill>
-                  <a:srgbClr val="4F7B80">
-                    <a:alpha val="80000"/>
-                  </a:srgbClr>
-                </a:solidFill>
-                <a:latin typeface="Montserrat" panose="02000505000000020004" pitchFamily="2" charset="77"/>
-              </a:rPr>
-              <a:t>STRICTLY</a:t>
-            </a:r>
-          </a:p>
-          <a:p>
-            <a:pPr algn="r"/>
-            <a:r>
-              <a:rPr lang="fr-FR" sz="800" b="0" spc="300" dirty="0">
-                <a:solidFill>
-                  <a:srgbClr val="4F7B80">
-                    <a:alpha val="80000"/>
-                  </a:srgbClr>
-                </a:solidFill>
-                <a:latin typeface="Montserrat" panose="02000505000000020004" pitchFamily="2" charset="77"/>
-              </a:rPr>
-              <a:t>CONFIDENTIAL</a:t>
-            </a:r>
-          </a:p>
-        </p:txBody>
-      </p:sp>
-      <p:sp>
-        <p:nvSpPr>
-          <p:cNvPr id="10" name="ZoneTexte 9">
-            <a:extLst>
-              <a:ext uri="{FF2B5EF4-FFF2-40B4-BE49-F238E27FC236}">
-                <a16:creationId xmlns:a16="http://schemas.microsoft.com/office/drawing/2014/main" id="{8077BFF4-3638-E443-A5EB-D7810F51FED1}"/>
-              </a:ext>
-            </a:extLst>
-          </p:cNvPr>
-          <p:cNvSpPr txBox="1"/>
-          <p:nvPr/>
-        </p:nvSpPr>
-        <p:spPr>
-          <a:xfrm>
-            <a:off x="9015610" y="6403769"/>
-            <a:ext cx="2615396" cy="295002"/>
-          </a:xfrm>
-          <a:prstGeom prst="rect">
-            <a:avLst/>
-          </a:prstGeom>
-        </p:spPr>
-        <p:txBody>
-          <a:bodyPr wrap="none" lIns="0" tIns="0" rIns="0" bIns="0" rtlCol="0" anchor="ctr" anchorCtr="0">
-            <a:noAutofit/>
-          </a:bodyPr>
-          <a:lstStyle/>
-          <a:p>
-            <a:pPr algn="r"/>
-            <a:fld id="{FA094B7F-545F-2F43-94BE-C484244EB6DF}" type="slidenum">
-              <a:rPr lang="fr-FR" sz="800" b="0" spc="300" smtClean="0">
-                <a:solidFill>
-                  <a:schemeClr val="tx1">
-                    <a:lumMod val="75000"/>
-                    <a:lumOff val="25000"/>
-                    <a:alpha val="80000"/>
-                  </a:schemeClr>
-                </a:solidFill>
-                <a:latin typeface="Montserrat" panose="02000505000000020004" pitchFamily="2" charset="77"/>
-              </a:rPr>
-              <a:t>‹#›</a:t>
-            </a:fld>
-            <a:endParaRPr lang="fr-FR" sz="800" b="0" spc="300" dirty="0">
-              <a:solidFill>
-                <a:schemeClr val="tx1">
-                  <a:lumMod val="75000"/>
-                  <a:lumOff val="25000"/>
-                  <a:alpha val="80000"/>
-                </a:schemeClr>
-              </a:solidFill>
-              <a:latin typeface="Montserrat" panose="02000505000000020004" pitchFamily="2" charset="77"/>
-            </a:endParaRPr>
-          </a:p>
-        </p:txBody>
-      </p:sp>
-      <p:sp>
-        <p:nvSpPr>
-          <p:cNvPr id="8" name="Espace réservé du texte 22">
-            <a:extLst>
-              <a:ext uri="{FF2B5EF4-FFF2-40B4-BE49-F238E27FC236}">
-                <a16:creationId xmlns:a16="http://schemas.microsoft.com/office/drawing/2014/main" id="{93398529-F411-7341-9172-76CFF0F5B668}"/>
-              </a:ext>
-            </a:extLst>
-          </p:cNvPr>
-          <p:cNvSpPr>
-            <a:spLocks noGrp="1"/>
-          </p:cNvSpPr>
-          <p:nvPr>
-            <p:ph type="body" sz="quarter" idx="23" hasCustomPrompt="1"/>
-          </p:nvPr>
-        </p:nvSpPr>
-        <p:spPr>
-          <a:xfrm>
-            <a:off x="560996" y="6449466"/>
-            <a:ext cx="3199887" cy="295002"/>
-          </a:xfrm>
-          <a:prstGeom prst="rect">
-            <a:avLst/>
-          </a:prstGeom>
-        </p:spPr>
-        <p:txBody>
-          <a:bodyPr/>
-          <a:lstStyle>
-            <a:lvl1pPr marL="0" marR="0" indent="0" algn="l" defTabSz="742755" rtl="0" eaLnBrk="1" fontAlgn="auto" latinLnBrk="0" hangingPunct="1">
-              <a:lnSpc>
-                <a:spcPct val="100000"/>
-              </a:lnSpc>
-              <a:spcBef>
-                <a:spcPts val="0"/>
-              </a:spcBef>
-              <a:spcAft>
-                <a:spcPts val="0"/>
-              </a:spcAft>
-              <a:buClrTx/>
-              <a:buSzTx/>
-              <a:buFontTx/>
-              <a:buNone/>
-              <a:tabLst/>
-              <a:defRPr lang="fr-FR" sz="800" b="0" i="0" baseline="0" smtClean="0">
-                <a:solidFill>
-                  <a:schemeClr val="tx1">
-                    <a:lumMod val="50000"/>
-                    <a:lumOff val="50000"/>
-                  </a:schemeClr>
-                </a:solidFill>
-                <a:effectLst/>
-                <a:latin typeface="Brown" pitchFamily="2" charset="77"/>
-              </a:defRPr>
-            </a:lvl1pPr>
-          </a:lstStyle>
-          <a:p>
-            <a:pPr marL="0" marR="0" lvl="0" indent="0" algn="l" defTabSz="742755" rtl="0" eaLnBrk="1" fontAlgn="auto" latinLnBrk="0" hangingPunct="1">
-              <a:lnSpc>
-                <a:spcPct val="100000"/>
-              </a:lnSpc>
-              <a:spcBef>
-                <a:spcPts val="0"/>
-              </a:spcBef>
-              <a:spcAft>
-                <a:spcPts val="0"/>
-              </a:spcAft>
-              <a:buClrTx/>
-              <a:buSzTx/>
-              <a:buFontTx/>
-              <a:buNone/>
-              <a:tabLst/>
-              <a:defRPr/>
-            </a:pPr>
-            <a:r>
-              <a:rPr kumimoji="0" lang="en-GB" sz="1083" b="0" i="0" u="none" strike="noStrike" kern="1200" cap="none" spc="0" normalizeH="0" baseline="0" noProof="0" dirty="0">
-                <a:ln>
-                  <a:noFill/>
-                </a:ln>
-                <a:solidFill>
-                  <a:srgbClr val="000000">
-                    <a:lumMod val="75000"/>
-                    <a:lumOff val="25000"/>
-                  </a:srgbClr>
-                </a:solidFill>
-                <a:effectLst/>
-                <a:uLnTx/>
-                <a:uFillTx/>
-                <a:latin typeface="Brown" pitchFamily="2" charset="77"/>
-                <a:ea typeface="+mn-ea"/>
-                <a:cs typeface="+mn-cs"/>
-              </a:rPr>
-              <a:t>Source : </a:t>
-            </a:r>
-            <a:r>
-              <a:rPr kumimoji="0" lang="en-GB" sz="1083" b="0" i="0" u="none" strike="noStrike" kern="1200" cap="none" spc="0" normalizeH="0" baseline="0" noProof="0" dirty="0" err="1">
-                <a:ln>
-                  <a:noFill/>
-                </a:ln>
-                <a:solidFill>
-                  <a:srgbClr val="000000">
-                    <a:lumMod val="75000"/>
-                    <a:lumOff val="25000"/>
-                  </a:srgbClr>
-                </a:solidFill>
-                <a:effectLst/>
-                <a:uLnTx/>
-                <a:uFillTx/>
-                <a:latin typeface="Brown" pitchFamily="2" charset="77"/>
-                <a:ea typeface="+mn-ea"/>
-                <a:cs typeface="+mn-cs"/>
-              </a:rPr>
-              <a:t>Shikohin</a:t>
-            </a:r>
-            <a:r>
-              <a:rPr kumimoji="0" lang="en-GB" sz="1083" b="0" i="0" u="none" strike="noStrike" kern="1200" cap="none" spc="0" normalizeH="0" baseline="0" noProof="0" dirty="0">
-                <a:ln>
-                  <a:noFill/>
-                </a:ln>
-                <a:solidFill>
-                  <a:srgbClr val="000000">
-                    <a:lumMod val="75000"/>
-                    <a:lumOff val="25000"/>
-                  </a:srgbClr>
-                </a:solidFill>
-                <a:effectLst/>
-                <a:uLnTx/>
-                <a:uFillTx/>
-                <a:latin typeface="Brown" pitchFamily="2" charset="77"/>
-                <a:ea typeface="+mn-ea"/>
-                <a:cs typeface="+mn-cs"/>
-              </a:rPr>
-              <a:t> Analysis</a:t>
-            </a:r>
-            <a:endParaRPr kumimoji="0" lang="en-GB" sz="1083" b="0" i="0" u="none" strike="noStrike" kern="1200" cap="none" spc="0" normalizeH="0" baseline="0" noProof="0" dirty="0">
-              <a:ln>
-                <a:noFill/>
-              </a:ln>
-              <a:solidFill>
-                <a:srgbClr val="000000">
-                  <a:lumMod val="75000"/>
-                  <a:lumOff val="25000"/>
-                </a:srgbClr>
-              </a:solidFill>
-              <a:effectLst/>
-              <a:uLnTx/>
-              <a:uFillTx/>
-              <a:latin typeface="+mn-lt"/>
-              <a:ea typeface="+mn-ea"/>
-              <a:cs typeface="+mn-cs"/>
-            </a:endParaRPr>
-          </a:p>
-        </p:txBody>
-      </p:sp>
-      <p:sp>
-        <p:nvSpPr>
-          <p:cNvPr id="4" name="ZoneTexte 3">
-            <a:extLst>
-              <a:ext uri="{FF2B5EF4-FFF2-40B4-BE49-F238E27FC236}">
-                <a16:creationId xmlns:a16="http://schemas.microsoft.com/office/drawing/2014/main" id="{1894EDFD-4D89-6946-AB42-99A4BA929E32}"/>
-              </a:ext>
-            </a:extLst>
-          </p:cNvPr>
-          <p:cNvSpPr txBox="1"/>
-          <p:nvPr/>
-        </p:nvSpPr>
-        <p:spPr>
-          <a:xfrm>
-            <a:off x="4914789" y="6528122"/>
-            <a:ext cx="0" cy="0"/>
-          </a:xfrm>
-          <a:prstGeom prst="rect">
-            <a:avLst/>
-          </a:prstGeom>
-        </p:spPr>
-        <p:txBody>
-          <a:bodyPr wrap="none" lIns="0" tIns="0" rIns="0" bIns="0" rtlCol="0" anchor="ctr" anchorCtr="0">
-            <a:noAutofit/>
-          </a:bodyPr>
-          <a:lstStyle/>
-          <a:p>
-            <a:pPr marL="0" marR="0" indent="0" algn="l" defTabSz="804320" rtl="0" eaLnBrk="1" fontAlgn="auto" latinLnBrk="0" hangingPunct="1">
-              <a:lnSpc>
-                <a:spcPct val="100000"/>
-              </a:lnSpc>
-              <a:spcBef>
-                <a:spcPts val="0"/>
-              </a:spcBef>
-              <a:spcAft>
-                <a:spcPts val="0"/>
-              </a:spcAft>
-              <a:buClrTx/>
-              <a:buSzTx/>
-              <a:buFontTx/>
-              <a:buNone/>
-              <a:tabLst/>
-              <a:defRPr/>
-            </a:pPr>
-            <a:endParaRPr lang="fr-FR" sz="800" b="1" dirty="0">
-              <a:solidFill>
-                <a:schemeClr val="tx1">
-                  <a:lumMod val="75000"/>
-                  <a:lumOff val="25000"/>
-                  <a:alpha val="80000"/>
-                </a:schemeClr>
-              </a:solidFill>
-              <a:latin typeface="Brown" pitchFamily="2" charset="77"/>
-            </a:endParaRPr>
-          </a:p>
-        </p:txBody>
-      </p:sp>
-      <p:sp>
-        <p:nvSpPr>
-          <p:cNvPr id="5" name="ZoneTexte 4">
-            <a:extLst>
-              <a:ext uri="{FF2B5EF4-FFF2-40B4-BE49-F238E27FC236}">
-                <a16:creationId xmlns:a16="http://schemas.microsoft.com/office/drawing/2014/main" id="{0A67ECF1-D872-764E-A916-4A4ABCC6977D}"/>
-              </a:ext>
-            </a:extLst>
-          </p:cNvPr>
-          <p:cNvSpPr txBox="1"/>
-          <p:nvPr/>
-        </p:nvSpPr>
-        <p:spPr>
-          <a:xfrm>
-            <a:off x="3443942" y="5238893"/>
-            <a:ext cx="1607735" cy="563766"/>
-          </a:xfrm>
-          <a:prstGeom prst="rect">
-            <a:avLst/>
-          </a:prstGeom>
-        </p:spPr>
-        <p:txBody>
-          <a:bodyPr wrap="square" lIns="0" tIns="0" rIns="0" bIns="0" rtlCol="0" anchor="ctr" anchorCtr="0">
-            <a:noAutofit/>
-          </a:bodyPr>
-          <a:lstStyle/>
-          <a:p>
-            <a:pPr algn="l"/>
-            <a:endParaRPr lang="fr-FR" sz="1400" b="1" dirty="0">
-              <a:solidFill>
-                <a:schemeClr val="tx1">
-                  <a:lumMod val="75000"/>
-                  <a:lumOff val="25000"/>
-                  <a:alpha val="80000"/>
-                </a:schemeClr>
-              </a:solidFill>
-            </a:endParaRPr>
-          </a:p>
-        </p:txBody>
-      </p:sp>
-      <p:sp>
-        <p:nvSpPr>
-          <p:cNvPr id="11" name="ZoneTexte 10">
-            <a:extLst>
-              <a:ext uri="{FF2B5EF4-FFF2-40B4-BE49-F238E27FC236}">
-                <a16:creationId xmlns:a16="http://schemas.microsoft.com/office/drawing/2014/main" id="{35999ACA-8A59-6344-BAB5-74813BBB1D08}"/>
-              </a:ext>
-            </a:extLst>
-          </p:cNvPr>
-          <p:cNvSpPr txBox="1"/>
-          <p:nvPr/>
-        </p:nvSpPr>
-        <p:spPr>
-          <a:xfrm>
-            <a:off x="4112731" y="6429146"/>
-            <a:ext cx="3966538" cy="408534"/>
-          </a:xfrm>
-          <a:prstGeom prst="rect">
-            <a:avLst/>
-          </a:prstGeom>
-        </p:spPr>
-        <p:txBody>
-          <a:bodyPr wrap="square" lIns="0" tIns="0" rIns="0" bIns="0" rtlCol="0" anchor="ctr" anchorCtr="0">
-            <a:noAutofit/>
-          </a:bodyPr>
-          <a:lstStyle/>
-          <a:p>
-            <a:pPr marL="0" marR="0" lvl="0" indent="0" algn="ctr" defTabSz="804320" rtl="0" eaLnBrk="1" fontAlgn="auto" latinLnBrk="0" hangingPunct="1">
-              <a:lnSpc>
-                <a:spcPct val="100000"/>
-              </a:lnSpc>
-              <a:spcBef>
-                <a:spcPts val="0"/>
-              </a:spcBef>
-              <a:spcAft>
-                <a:spcPts val="0"/>
-              </a:spcAft>
-              <a:buClrTx/>
-              <a:buSzTx/>
-              <a:buFontTx/>
-              <a:buNone/>
-              <a:tabLst/>
-              <a:defRPr/>
-            </a:pPr>
-            <a:r>
-              <a:rPr kumimoji="0" lang="fr-FR" sz="810" b="0" i="0" u="none" strike="noStrike" kern="1200" cap="none" spc="0" normalizeH="0" baseline="0" noProof="0" dirty="0">
-                <a:ln>
-                  <a:noFill/>
-                </a:ln>
-                <a:solidFill>
-                  <a:schemeClr val="bg1">
-                    <a:lumMod val="65000"/>
-                  </a:schemeClr>
-                </a:solidFill>
-                <a:effectLst/>
-                <a:uLnTx/>
-                <a:uFillTx/>
-                <a:latin typeface="Brown" pitchFamily="2" charset="77"/>
-                <a:ea typeface="+mn-ea"/>
-                <a:cs typeface="+mn-cs"/>
-              </a:rPr>
-              <a:t>Copyright© 2021 Shikohin, Inc. All </a:t>
-            </a:r>
-            <a:r>
-              <a:rPr kumimoji="0" lang="fr-FR" sz="810" b="0" i="0" u="none" strike="noStrike" kern="1200" cap="none" spc="0" normalizeH="0" baseline="0" noProof="0" dirty="0" err="1">
-                <a:ln>
-                  <a:noFill/>
-                </a:ln>
-                <a:solidFill>
-                  <a:schemeClr val="bg1">
-                    <a:lumMod val="65000"/>
-                  </a:schemeClr>
-                </a:solidFill>
-                <a:effectLst/>
-                <a:uLnTx/>
-                <a:uFillTx/>
-                <a:latin typeface="Brown" pitchFamily="2" charset="77"/>
-                <a:ea typeface="+mn-ea"/>
-                <a:cs typeface="+mn-cs"/>
-              </a:rPr>
-              <a:t>rights</a:t>
-            </a:r>
-            <a:r>
-              <a:rPr kumimoji="0" lang="fr-FR" sz="810" b="0" i="0" u="none" strike="noStrike" kern="1200" cap="none" spc="0" normalizeH="0" baseline="0" noProof="0" dirty="0">
-                <a:ln>
-                  <a:noFill/>
-                </a:ln>
-                <a:solidFill>
-                  <a:schemeClr val="bg1">
-                    <a:lumMod val="65000"/>
-                  </a:schemeClr>
-                </a:solidFill>
-                <a:effectLst/>
-                <a:uLnTx/>
-                <a:uFillTx/>
-                <a:latin typeface="Brown" pitchFamily="2" charset="77"/>
-                <a:ea typeface="+mn-ea"/>
-                <a:cs typeface="+mn-cs"/>
-              </a:rPr>
-              <a:t> </a:t>
-            </a:r>
-            <a:r>
-              <a:rPr kumimoji="0" lang="fr-FR" sz="810" b="0" i="0" u="none" strike="noStrike" kern="1200" cap="none" spc="0" normalizeH="0" baseline="0" noProof="0" dirty="0" err="1">
-                <a:ln>
-                  <a:noFill/>
-                </a:ln>
-                <a:solidFill>
-                  <a:schemeClr val="bg1">
-                    <a:lumMod val="65000"/>
-                  </a:schemeClr>
-                </a:solidFill>
-                <a:effectLst/>
-                <a:uLnTx/>
-                <a:uFillTx/>
-                <a:latin typeface="Brown" pitchFamily="2" charset="77"/>
-                <a:ea typeface="+mn-ea"/>
-                <a:cs typeface="+mn-cs"/>
-              </a:rPr>
-              <a:t>reserved</a:t>
-            </a:r>
-            <a:r>
-              <a:rPr kumimoji="0" lang="fr-FR" sz="810" b="0" i="0" u="none" strike="noStrike" kern="1200" cap="none" spc="0" normalizeH="0" baseline="0" noProof="0" dirty="0">
-                <a:ln>
-                  <a:noFill/>
-                </a:ln>
-                <a:solidFill>
-                  <a:schemeClr val="bg1">
-                    <a:lumMod val="65000"/>
-                  </a:schemeClr>
-                </a:solidFill>
-                <a:effectLst/>
-                <a:uLnTx/>
-                <a:uFillTx/>
-                <a:latin typeface="Brown" pitchFamily="2" charset="77"/>
-                <a:ea typeface="+mn-ea"/>
-                <a:cs typeface="+mn-cs"/>
-              </a:rPr>
-              <a:t>.</a:t>
-            </a:r>
-            <a:endParaRPr kumimoji="0" lang="fr-FR" sz="810" b="1" i="0" u="none" strike="noStrike" kern="1200" cap="none" spc="0" normalizeH="0" baseline="0" noProof="0" dirty="0">
-              <a:ln>
-                <a:noFill/>
-              </a:ln>
-              <a:solidFill>
-                <a:schemeClr val="bg1">
-                  <a:lumMod val="65000"/>
-                </a:schemeClr>
-              </a:solidFill>
-              <a:effectLst/>
-              <a:uLnTx/>
-              <a:uFillTx/>
-              <a:latin typeface="Brown" pitchFamily="2" charset="77"/>
-              <a:ea typeface="+mn-ea"/>
-              <a:cs typeface="+mn-cs"/>
-            </a:endParaRPr>
-          </a:p>
-          <a:p>
-            <a:pPr algn="ctr"/>
-            <a:endParaRPr lang="fr-FR" sz="810" b="1" baseline="0" dirty="0">
-              <a:solidFill>
-                <a:schemeClr val="bg1">
-                  <a:lumMod val="65000"/>
-                </a:schemeClr>
-              </a:solidFill>
-              <a:latin typeface="Brown" pitchFamily="2" charset="77"/>
-            </a:endParaRPr>
-          </a:p>
-        </p:txBody>
-      </p:sp>
-    </p:spTree>
-    <p:extLst>
-      <p:ext uri="{BB962C8B-B14F-4D97-AF65-F5344CB8AC3E}">
-        <p14:creationId xmlns:p14="http://schemas.microsoft.com/office/powerpoint/2010/main" val="1024902377"/>
-      </p:ext>
-    </p:extLst>
-  </p:cSld>
-  <p:clrMapOvr>
-    <a:masterClrMapping/>
-  </p:clrMapOvr>
-  <mc:AlternateContent xmlns:mc="http://schemas.openxmlformats.org/markup-compatibility/2006" xmlns:p14="http://schemas.microsoft.com/office/powerpoint/2010/main">
-    <mc:Choice Requires="p14">
-      <p:transition spd="slow" p14:dur="1200">
-        <p14:prism dir="u"/>
-      </p:transition>
-    </mc:Choice>
-    <mc:Fallback xmlns="">
-      <p:transition spd="slow">
-        <p:fade/>
-      </p:transition>
-    </mc:Fallback>
-  </mc:AlternateContent>
-  <p:hf sldNum="0" hdr="0" ftr="0"/>
-</p:sldLayout>
-</file>
-
-<file path=ppt/slideLayouts/slideLayout20.xml><?xml version="1.0" encoding="utf-8"?>
 <p:sldLayout xmlns:a="http://schemas.openxmlformats.org/drawingml/2006/main" xmlns:r="http://schemas.openxmlformats.org/officeDocument/2006/relationships" xmlns:p="http://schemas.openxmlformats.org/presentationml/2006/main" userDrawn="1">
   <p:cSld name="OK_content">
     <p:spTree>
@@ -8584,7 +7480,7 @@
 </p:sldLayout>
 </file>
 
-<file path=ppt/slideLayouts/slideLayout21.xml><?xml version="1.0" encoding="utf-8"?>
+<file path=ppt/slideLayouts/slideLayout19.xml><?xml version="1.0" encoding="utf-8"?>
 <p:sldLayout xmlns:a="http://schemas.openxmlformats.org/drawingml/2006/main" xmlns:r="http://schemas.openxmlformats.org/officeDocument/2006/relationships" xmlns:p="http://schemas.openxmlformats.org/presentationml/2006/main" preserve="1" userDrawn="1">
   <p:cSld name="Technical Center">
     <p:bg>
@@ -8690,7 +7586,7 @@
                   <a:schemeClr val="bg1"/>
                 </a:solidFill>
               </a:rPr>
-              <a:t>17 March 2026</a:t>
+              <a:t>18 March 2026</a:t>
             </a:fld>
             <a:endParaRPr lang="en-FI" sz="800" dirty="0">
               <a:solidFill>
@@ -8783,7 +7679,710 @@
 </p:sldLayout>
 </file>
 
-<file path=ppt/slideLayouts/slideLayout22.xml><?xml version="1.0" encoding="utf-8"?>
+<file path=ppt/slideLayouts/slideLayout2.xml><?xml version="1.0" encoding="utf-8"?>
+<p:sldLayout xmlns:a="http://schemas.openxmlformats.org/drawingml/2006/main" xmlns:r="http://schemas.openxmlformats.org/officeDocument/2006/relationships" xmlns:p="http://schemas.openxmlformats.org/presentationml/2006/main" preserve="1">
+  <p:cSld name="1_Disposition personnalisée">
+    <p:spTree>
+      <p:nvGrpSpPr>
+        <p:cNvPr id="1" name=""/>
+        <p:cNvGrpSpPr/>
+        <p:nvPr/>
+      </p:nvGrpSpPr>
+      <p:grpSpPr>
+        <a:xfrm>
+          <a:off x="0" y="0"/>
+          <a:ext cx="0" cy="0"/>
+          <a:chOff x="0" y="0"/>
+          <a:chExt cx="0" cy="0"/>
+        </a:xfrm>
+      </p:grpSpPr>
+      <p:sp>
+        <p:nvSpPr>
+          <p:cNvPr id="9" name="Rectangle 8">
+            <a:extLst>
+              <a:ext uri="{FF2B5EF4-FFF2-40B4-BE49-F238E27FC236}">
+                <a16:creationId xmlns:a16="http://schemas.microsoft.com/office/drawing/2014/main" id="{740FA9FB-A6BA-AD43-B17A-3E6D7C1DCDD4}"/>
+              </a:ext>
+            </a:extLst>
+          </p:cNvPr>
+          <p:cNvSpPr/>
+          <p:nvPr/>
+        </p:nvSpPr>
+        <p:spPr bwMode="auto">
+          <a:xfrm>
+            <a:off x="609599" y="620155"/>
+            <a:ext cx="10991850" cy="5726857"/>
+          </a:xfrm>
+          <a:prstGeom prst="rect">
+            <a:avLst/>
+          </a:prstGeom>
+          <a:solidFill>
+            <a:srgbClr val="F8F6F3">
+              <a:alpha val="51765"/>
+            </a:srgbClr>
+          </a:solidFill>
+          <a:ln>
+            <a:noFill/>
+          </a:ln>
+        </p:spPr>
+        <p:txBody>
+          <a:bodyPr vert="horz" wrap="square" lIns="49530" tIns="24765" rIns="49530" bIns="24765" numCol="1" rtlCol="0" anchor="t" anchorCtr="0" compatLnSpc="1">
+            <a:prstTxWarp prst="textNoShape">
+              <a:avLst/>
+            </a:prstTxWarp>
+          </a:bodyPr>
+          <a:lstStyle/>
+          <a:p>
+            <a:pPr algn="ctr"/>
+            <a:endParaRPr lang="fr-FR" sz="858" dirty="0"/>
+          </a:p>
+        </p:txBody>
+      </p:sp>
+      <p:sp>
+        <p:nvSpPr>
+          <p:cNvPr id="6" name="Espace réservé du texte 5">
+            <a:extLst>
+              <a:ext uri="{FF2B5EF4-FFF2-40B4-BE49-F238E27FC236}">
+                <a16:creationId xmlns:a16="http://schemas.microsoft.com/office/drawing/2014/main" id="{4287D38D-5798-F546-AAAE-D178455CEE7B}"/>
+              </a:ext>
+            </a:extLst>
+          </p:cNvPr>
+          <p:cNvSpPr>
+            <a:spLocks noGrp="1"/>
+          </p:cNvSpPr>
+          <p:nvPr>
+            <p:ph type="body" sz="quarter" idx="12" hasCustomPrompt="1"/>
+          </p:nvPr>
+        </p:nvSpPr>
+        <p:spPr>
+          <a:xfrm>
+            <a:off x="508000" y="242123"/>
+            <a:ext cx="5172576" cy="386499"/>
+          </a:xfrm>
+          <a:prstGeom prst="rect">
+            <a:avLst/>
+          </a:prstGeom>
+        </p:spPr>
+        <p:txBody>
+          <a:bodyPr/>
+          <a:lstStyle>
+            <a:lvl1pPr>
+              <a:defRPr sz="900" b="1" i="0" cap="all" spc="300" baseline="0">
+                <a:solidFill>
+                  <a:schemeClr val="tx1">
+                    <a:lumMod val="65000"/>
+                    <a:lumOff val="35000"/>
+                  </a:schemeClr>
+                </a:solidFill>
+                <a:latin typeface="Brown" pitchFamily="2" charset="77"/>
+              </a:defRPr>
+            </a:lvl1pPr>
+            <a:lvl2pPr>
+              <a:defRPr sz="900" b="1" spc="300">
+                <a:solidFill>
+                  <a:schemeClr val="tx1">
+                    <a:lumMod val="75000"/>
+                    <a:lumOff val="25000"/>
+                  </a:schemeClr>
+                </a:solidFill>
+              </a:defRPr>
+            </a:lvl2pPr>
+            <a:lvl3pPr>
+              <a:defRPr sz="900" b="1" spc="300">
+                <a:solidFill>
+                  <a:schemeClr val="tx1">
+                    <a:lumMod val="75000"/>
+                    <a:lumOff val="25000"/>
+                  </a:schemeClr>
+                </a:solidFill>
+              </a:defRPr>
+            </a:lvl3pPr>
+            <a:lvl4pPr>
+              <a:defRPr sz="900" b="1" spc="300">
+                <a:solidFill>
+                  <a:schemeClr val="tx1">
+                    <a:lumMod val="75000"/>
+                    <a:lumOff val="25000"/>
+                  </a:schemeClr>
+                </a:solidFill>
+              </a:defRPr>
+            </a:lvl4pPr>
+            <a:lvl5pPr>
+              <a:defRPr sz="900" b="1" spc="300">
+                <a:solidFill>
+                  <a:schemeClr val="tx1">
+                    <a:lumMod val="75000"/>
+                    <a:lumOff val="25000"/>
+                  </a:schemeClr>
+                </a:solidFill>
+              </a:defRPr>
+            </a:lvl5pPr>
+          </a:lstStyle>
+          <a:p>
+            <a:pPr lvl="0"/>
+            <a:r>
+              <a:rPr lang="fr-FR" dirty="0"/>
+              <a:t>BASIC SLIDE COMPOSITION </a:t>
+            </a:r>
+          </a:p>
+        </p:txBody>
+      </p:sp>
+      <p:sp>
+        <p:nvSpPr>
+          <p:cNvPr id="2" name="ZoneTexte 1">
+            <a:extLst>
+              <a:ext uri="{FF2B5EF4-FFF2-40B4-BE49-F238E27FC236}">
+                <a16:creationId xmlns:a16="http://schemas.microsoft.com/office/drawing/2014/main" id="{9E438AA4-7DC6-424C-B339-C11671851E37}"/>
+              </a:ext>
+            </a:extLst>
+          </p:cNvPr>
+          <p:cNvSpPr txBox="1"/>
+          <p:nvPr/>
+        </p:nvSpPr>
+        <p:spPr>
+          <a:xfrm>
+            <a:off x="8986053" y="189092"/>
+            <a:ext cx="2615396" cy="295002"/>
+          </a:xfrm>
+          <a:prstGeom prst="rect">
+            <a:avLst/>
+          </a:prstGeom>
+        </p:spPr>
+        <p:txBody>
+          <a:bodyPr wrap="none" lIns="0" tIns="0" rIns="0" bIns="0" rtlCol="0" anchor="ctr" anchorCtr="0">
+            <a:noAutofit/>
+          </a:bodyPr>
+          <a:lstStyle/>
+          <a:p>
+            <a:pPr algn="r"/>
+            <a:r>
+              <a:rPr lang="fr-FR" sz="800" b="0" spc="300" dirty="0">
+                <a:solidFill>
+                  <a:srgbClr val="4F7B80">
+                    <a:alpha val="80000"/>
+                  </a:srgbClr>
+                </a:solidFill>
+                <a:latin typeface="Montserrat" panose="02000505000000020004" pitchFamily="2" charset="77"/>
+              </a:rPr>
+              <a:t>STRICTLY</a:t>
+            </a:r>
+          </a:p>
+          <a:p>
+            <a:pPr algn="r"/>
+            <a:r>
+              <a:rPr lang="fr-FR" sz="800" b="0" spc="300" dirty="0">
+                <a:solidFill>
+                  <a:srgbClr val="4F7B80">
+                    <a:alpha val="80000"/>
+                  </a:srgbClr>
+                </a:solidFill>
+                <a:latin typeface="Montserrat" panose="02000505000000020004" pitchFamily="2" charset="77"/>
+              </a:rPr>
+              <a:t>CONFIDENTIAL</a:t>
+            </a:r>
+          </a:p>
+        </p:txBody>
+      </p:sp>
+      <p:sp>
+        <p:nvSpPr>
+          <p:cNvPr id="10" name="ZoneTexte 9">
+            <a:extLst>
+              <a:ext uri="{FF2B5EF4-FFF2-40B4-BE49-F238E27FC236}">
+                <a16:creationId xmlns:a16="http://schemas.microsoft.com/office/drawing/2014/main" id="{8077BFF4-3638-E443-A5EB-D7810F51FED1}"/>
+              </a:ext>
+            </a:extLst>
+          </p:cNvPr>
+          <p:cNvSpPr txBox="1"/>
+          <p:nvPr/>
+        </p:nvSpPr>
+        <p:spPr>
+          <a:xfrm>
+            <a:off x="9015610" y="6403769"/>
+            <a:ext cx="2615396" cy="295002"/>
+          </a:xfrm>
+          <a:prstGeom prst="rect">
+            <a:avLst/>
+          </a:prstGeom>
+        </p:spPr>
+        <p:txBody>
+          <a:bodyPr wrap="none" lIns="0" tIns="0" rIns="0" bIns="0" rtlCol="0" anchor="ctr" anchorCtr="0">
+            <a:noAutofit/>
+          </a:bodyPr>
+          <a:lstStyle/>
+          <a:p>
+            <a:pPr algn="r"/>
+            <a:fld id="{FA094B7F-545F-2F43-94BE-C484244EB6DF}" type="slidenum">
+              <a:rPr lang="fr-FR" sz="800" b="0" spc="300" smtClean="0">
+                <a:solidFill>
+                  <a:schemeClr val="tx1">
+                    <a:lumMod val="75000"/>
+                    <a:lumOff val="25000"/>
+                    <a:alpha val="80000"/>
+                  </a:schemeClr>
+                </a:solidFill>
+                <a:latin typeface="Montserrat" panose="02000505000000020004" pitchFamily="2" charset="77"/>
+              </a:rPr>
+              <a:t>‹#›</a:t>
+            </a:fld>
+            <a:endParaRPr lang="fr-FR" sz="800" b="0" spc="300" dirty="0">
+              <a:solidFill>
+                <a:schemeClr val="tx1">
+                  <a:lumMod val="75000"/>
+                  <a:lumOff val="25000"/>
+                  <a:alpha val="80000"/>
+                </a:schemeClr>
+              </a:solidFill>
+              <a:latin typeface="Montserrat" panose="02000505000000020004" pitchFamily="2" charset="77"/>
+            </a:endParaRPr>
+          </a:p>
+        </p:txBody>
+      </p:sp>
+      <p:sp>
+        <p:nvSpPr>
+          <p:cNvPr id="8" name="Espace réservé du texte 22">
+            <a:extLst>
+              <a:ext uri="{FF2B5EF4-FFF2-40B4-BE49-F238E27FC236}">
+                <a16:creationId xmlns:a16="http://schemas.microsoft.com/office/drawing/2014/main" id="{93398529-F411-7341-9172-76CFF0F5B668}"/>
+              </a:ext>
+            </a:extLst>
+          </p:cNvPr>
+          <p:cNvSpPr>
+            <a:spLocks noGrp="1"/>
+          </p:cNvSpPr>
+          <p:nvPr>
+            <p:ph type="body" sz="quarter" idx="23" hasCustomPrompt="1"/>
+          </p:nvPr>
+        </p:nvSpPr>
+        <p:spPr>
+          <a:xfrm>
+            <a:off x="560996" y="6449466"/>
+            <a:ext cx="3199887" cy="295002"/>
+          </a:xfrm>
+          <a:prstGeom prst="rect">
+            <a:avLst/>
+          </a:prstGeom>
+        </p:spPr>
+        <p:txBody>
+          <a:bodyPr/>
+          <a:lstStyle>
+            <a:lvl1pPr marL="0" marR="0" indent="0" algn="l" defTabSz="742755" rtl="0" eaLnBrk="1" fontAlgn="auto" latinLnBrk="0" hangingPunct="1">
+              <a:lnSpc>
+                <a:spcPct val="100000"/>
+              </a:lnSpc>
+              <a:spcBef>
+                <a:spcPts val="0"/>
+              </a:spcBef>
+              <a:spcAft>
+                <a:spcPts val="0"/>
+              </a:spcAft>
+              <a:buClrTx/>
+              <a:buSzTx/>
+              <a:buFontTx/>
+              <a:buNone/>
+              <a:tabLst/>
+              <a:defRPr lang="fr-FR" sz="800" b="0" i="0" baseline="0" smtClean="0">
+                <a:solidFill>
+                  <a:schemeClr val="tx1">
+                    <a:lumMod val="50000"/>
+                    <a:lumOff val="50000"/>
+                  </a:schemeClr>
+                </a:solidFill>
+                <a:effectLst/>
+                <a:latin typeface="Brown" pitchFamily="2" charset="77"/>
+              </a:defRPr>
+            </a:lvl1pPr>
+          </a:lstStyle>
+          <a:p>
+            <a:pPr marL="0" marR="0" lvl="0" indent="0" algn="l" defTabSz="742755" rtl="0" eaLnBrk="1" fontAlgn="auto" latinLnBrk="0" hangingPunct="1">
+              <a:lnSpc>
+                <a:spcPct val="100000"/>
+              </a:lnSpc>
+              <a:spcBef>
+                <a:spcPts val="0"/>
+              </a:spcBef>
+              <a:spcAft>
+                <a:spcPts val="0"/>
+              </a:spcAft>
+              <a:buClrTx/>
+              <a:buSzTx/>
+              <a:buFontTx/>
+              <a:buNone/>
+              <a:tabLst/>
+              <a:defRPr/>
+            </a:pPr>
+            <a:r>
+              <a:rPr kumimoji="0" lang="en-GB" sz="1083" b="0" i="0" u="none" strike="noStrike" kern="1200" cap="none" spc="0" normalizeH="0" baseline="0" noProof="0" dirty="0">
+                <a:ln>
+                  <a:noFill/>
+                </a:ln>
+                <a:solidFill>
+                  <a:srgbClr val="000000">
+                    <a:lumMod val="75000"/>
+                    <a:lumOff val="25000"/>
+                  </a:srgbClr>
+                </a:solidFill>
+                <a:effectLst/>
+                <a:uLnTx/>
+                <a:uFillTx/>
+                <a:latin typeface="Brown" pitchFamily="2" charset="77"/>
+                <a:ea typeface="+mn-ea"/>
+                <a:cs typeface="+mn-cs"/>
+              </a:rPr>
+              <a:t>Source : </a:t>
+            </a:r>
+            <a:r>
+              <a:rPr kumimoji="0" lang="en-GB" sz="1083" b="0" i="0" u="none" strike="noStrike" kern="1200" cap="none" spc="0" normalizeH="0" baseline="0" noProof="0" dirty="0" err="1">
+                <a:ln>
+                  <a:noFill/>
+                </a:ln>
+                <a:solidFill>
+                  <a:srgbClr val="000000">
+                    <a:lumMod val="75000"/>
+                    <a:lumOff val="25000"/>
+                  </a:srgbClr>
+                </a:solidFill>
+                <a:effectLst/>
+                <a:uLnTx/>
+                <a:uFillTx/>
+                <a:latin typeface="Brown" pitchFamily="2" charset="77"/>
+                <a:ea typeface="+mn-ea"/>
+                <a:cs typeface="+mn-cs"/>
+              </a:rPr>
+              <a:t>Shikohin</a:t>
+            </a:r>
+            <a:r>
+              <a:rPr kumimoji="0" lang="en-GB" sz="1083" b="0" i="0" u="none" strike="noStrike" kern="1200" cap="none" spc="0" normalizeH="0" baseline="0" noProof="0" dirty="0">
+                <a:ln>
+                  <a:noFill/>
+                </a:ln>
+                <a:solidFill>
+                  <a:srgbClr val="000000">
+                    <a:lumMod val="75000"/>
+                    <a:lumOff val="25000"/>
+                  </a:srgbClr>
+                </a:solidFill>
+                <a:effectLst/>
+                <a:uLnTx/>
+                <a:uFillTx/>
+                <a:latin typeface="Brown" pitchFamily="2" charset="77"/>
+                <a:ea typeface="+mn-ea"/>
+                <a:cs typeface="+mn-cs"/>
+              </a:rPr>
+              <a:t> Analysis</a:t>
+            </a:r>
+            <a:endParaRPr kumimoji="0" lang="en-GB" sz="1083" b="0" i="0" u="none" strike="noStrike" kern="1200" cap="none" spc="0" normalizeH="0" baseline="0" noProof="0" dirty="0">
+              <a:ln>
+                <a:noFill/>
+              </a:ln>
+              <a:solidFill>
+                <a:srgbClr val="000000">
+                  <a:lumMod val="75000"/>
+                  <a:lumOff val="25000"/>
+                </a:srgbClr>
+              </a:solidFill>
+              <a:effectLst/>
+              <a:uLnTx/>
+              <a:uFillTx/>
+              <a:latin typeface="+mn-lt"/>
+              <a:ea typeface="+mn-ea"/>
+              <a:cs typeface="+mn-cs"/>
+            </a:endParaRPr>
+          </a:p>
+        </p:txBody>
+      </p:sp>
+      <p:sp>
+        <p:nvSpPr>
+          <p:cNvPr id="4" name="ZoneTexte 3">
+            <a:extLst>
+              <a:ext uri="{FF2B5EF4-FFF2-40B4-BE49-F238E27FC236}">
+                <a16:creationId xmlns:a16="http://schemas.microsoft.com/office/drawing/2014/main" id="{1894EDFD-4D89-6946-AB42-99A4BA929E32}"/>
+              </a:ext>
+            </a:extLst>
+          </p:cNvPr>
+          <p:cNvSpPr txBox="1"/>
+          <p:nvPr/>
+        </p:nvSpPr>
+        <p:spPr>
+          <a:xfrm>
+            <a:off x="4914789" y="6528122"/>
+            <a:ext cx="0" cy="0"/>
+          </a:xfrm>
+          <a:prstGeom prst="rect">
+            <a:avLst/>
+          </a:prstGeom>
+        </p:spPr>
+        <p:txBody>
+          <a:bodyPr wrap="none" lIns="0" tIns="0" rIns="0" bIns="0" rtlCol="0" anchor="ctr" anchorCtr="0">
+            <a:noAutofit/>
+          </a:bodyPr>
+          <a:lstStyle/>
+          <a:p>
+            <a:pPr marL="0" marR="0" indent="0" algn="l" defTabSz="804320" rtl="0" eaLnBrk="1" fontAlgn="auto" latinLnBrk="0" hangingPunct="1">
+              <a:lnSpc>
+                <a:spcPct val="100000"/>
+              </a:lnSpc>
+              <a:spcBef>
+                <a:spcPts val="0"/>
+              </a:spcBef>
+              <a:spcAft>
+                <a:spcPts val="0"/>
+              </a:spcAft>
+              <a:buClrTx/>
+              <a:buSzTx/>
+              <a:buFontTx/>
+              <a:buNone/>
+              <a:tabLst/>
+              <a:defRPr/>
+            </a:pPr>
+            <a:endParaRPr lang="fr-FR" sz="800" b="1" dirty="0">
+              <a:solidFill>
+                <a:schemeClr val="tx1">
+                  <a:lumMod val="75000"/>
+                  <a:lumOff val="25000"/>
+                  <a:alpha val="80000"/>
+                </a:schemeClr>
+              </a:solidFill>
+              <a:latin typeface="Brown" pitchFamily="2" charset="77"/>
+            </a:endParaRPr>
+          </a:p>
+        </p:txBody>
+      </p:sp>
+      <p:sp>
+        <p:nvSpPr>
+          <p:cNvPr id="5" name="ZoneTexte 4">
+            <a:extLst>
+              <a:ext uri="{FF2B5EF4-FFF2-40B4-BE49-F238E27FC236}">
+                <a16:creationId xmlns:a16="http://schemas.microsoft.com/office/drawing/2014/main" id="{0A67ECF1-D872-764E-A916-4A4ABCC6977D}"/>
+              </a:ext>
+            </a:extLst>
+          </p:cNvPr>
+          <p:cNvSpPr txBox="1"/>
+          <p:nvPr/>
+        </p:nvSpPr>
+        <p:spPr>
+          <a:xfrm>
+            <a:off x="3443942" y="5238893"/>
+            <a:ext cx="1607735" cy="563766"/>
+          </a:xfrm>
+          <a:prstGeom prst="rect">
+            <a:avLst/>
+          </a:prstGeom>
+        </p:spPr>
+        <p:txBody>
+          <a:bodyPr wrap="square" lIns="0" tIns="0" rIns="0" bIns="0" rtlCol="0" anchor="ctr" anchorCtr="0">
+            <a:noAutofit/>
+          </a:bodyPr>
+          <a:lstStyle/>
+          <a:p>
+            <a:pPr algn="l"/>
+            <a:endParaRPr lang="fr-FR" sz="1400" b="1" dirty="0">
+              <a:solidFill>
+                <a:schemeClr val="tx1">
+                  <a:lumMod val="75000"/>
+                  <a:lumOff val="25000"/>
+                  <a:alpha val="80000"/>
+                </a:schemeClr>
+              </a:solidFill>
+            </a:endParaRPr>
+          </a:p>
+        </p:txBody>
+      </p:sp>
+      <p:sp>
+        <p:nvSpPr>
+          <p:cNvPr id="11" name="ZoneTexte 10">
+            <a:extLst>
+              <a:ext uri="{FF2B5EF4-FFF2-40B4-BE49-F238E27FC236}">
+                <a16:creationId xmlns:a16="http://schemas.microsoft.com/office/drawing/2014/main" id="{35999ACA-8A59-6344-BAB5-74813BBB1D08}"/>
+              </a:ext>
+            </a:extLst>
+          </p:cNvPr>
+          <p:cNvSpPr txBox="1"/>
+          <p:nvPr/>
+        </p:nvSpPr>
+        <p:spPr>
+          <a:xfrm>
+            <a:off x="4112731" y="6429146"/>
+            <a:ext cx="3966538" cy="408534"/>
+          </a:xfrm>
+          <a:prstGeom prst="rect">
+            <a:avLst/>
+          </a:prstGeom>
+        </p:spPr>
+        <p:txBody>
+          <a:bodyPr wrap="square" lIns="0" tIns="0" rIns="0" bIns="0" rtlCol="0" anchor="ctr" anchorCtr="0">
+            <a:noAutofit/>
+          </a:bodyPr>
+          <a:lstStyle/>
+          <a:p>
+            <a:pPr marL="0" marR="0" lvl="0" indent="0" algn="ctr" defTabSz="804320" rtl="0" eaLnBrk="1" fontAlgn="auto" latinLnBrk="0" hangingPunct="1">
+              <a:lnSpc>
+                <a:spcPct val="100000"/>
+              </a:lnSpc>
+              <a:spcBef>
+                <a:spcPts val="0"/>
+              </a:spcBef>
+              <a:spcAft>
+                <a:spcPts val="0"/>
+              </a:spcAft>
+              <a:buClrTx/>
+              <a:buSzTx/>
+              <a:buFontTx/>
+              <a:buNone/>
+              <a:tabLst/>
+              <a:defRPr/>
+            </a:pPr>
+            <a:r>
+              <a:rPr kumimoji="0" lang="fr-FR" sz="810" b="0" i="0" u="none" strike="noStrike" kern="1200" cap="none" spc="0" normalizeH="0" baseline="0" noProof="0" dirty="0">
+                <a:ln>
+                  <a:noFill/>
+                </a:ln>
+                <a:solidFill>
+                  <a:schemeClr val="bg1">
+                    <a:lumMod val="65000"/>
+                  </a:schemeClr>
+                </a:solidFill>
+                <a:effectLst/>
+                <a:uLnTx/>
+                <a:uFillTx/>
+                <a:latin typeface="Brown" pitchFamily="2" charset="77"/>
+                <a:ea typeface="+mn-ea"/>
+                <a:cs typeface="+mn-cs"/>
+              </a:rPr>
+              <a:t>Copyright© 2021 Shikohin, Inc. All </a:t>
+            </a:r>
+            <a:r>
+              <a:rPr kumimoji="0" lang="fr-FR" sz="810" b="0" i="0" u="none" strike="noStrike" kern="1200" cap="none" spc="0" normalizeH="0" baseline="0" noProof="0" dirty="0" err="1">
+                <a:ln>
+                  <a:noFill/>
+                </a:ln>
+                <a:solidFill>
+                  <a:schemeClr val="bg1">
+                    <a:lumMod val="65000"/>
+                  </a:schemeClr>
+                </a:solidFill>
+                <a:effectLst/>
+                <a:uLnTx/>
+                <a:uFillTx/>
+                <a:latin typeface="Brown" pitchFamily="2" charset="77"/>
+                <a:ea typeface="+mn-ea"/>
+                <a:cs typeface="+mn-cs"/>
+              </a:rPr>
+              <a:t>rights</a:t>
+            </a:r>
+            <a:r>
+              <a:rPr kumimoji="0" lang="fr-FR" sz="810" b="0" i="0" u="none" strike="noStrike" kern="1200" cap="none" spc="0" normalizeH="0" baseline="0" noProof="0" dirty="0">
+                <a:ln>
+                  <a:noFill/>
+                </a:ln>
+                <a:solidFill>
+                  <a:schemeClr val="bg1">
+                    <a:lumMod val="65000"/>
+                  </a:schemeClr>
+                </a:solidFill>
+                <a:effectLst/>
+                <a:uLnTx/>
+                <a:uFillTx/>
+                <a:latin typeface="Brown" pitchFamily="2" charset="77"/>
+                <a:ea typeface="+mn-ea"/>
+                <a:cs typeface="+mn-cs"/>
+              </a:rPr>
+              <a:t> </a:t>
+            </a:r>
+            <a:r>
+              <a:rPr kumimoji="0" lang="fr-FR" sz="810" b="0" i="0" u="none" strike="noStrike" kern="1200" cap="none" spc="0" normalizeH="0" baseline="0" noProof="0" dirty="0" err="1">
+                <a:ln>
+                  <a:noFill/>
+                </a:ln>
+                <a:solidFill>
+                  <a:schemeClr val="bg1">
+                    <a:lumMod val="65000"/>
+                  </a:schemeClr>
+                </a:solidFill>
+                <a:effectLst/>
+                <a:uLnTx/>
+                <a:uFillTx/>
+                <a:latin typeface="Brown" pitchFamily="2" charset="77"/>
+                <a:ea typeface="+mn-ea"/>
+                <a:cs typeface="+mn-cs"/>
+              </a:rPr>
+              <a:t>reserved</a:t>
+            </a:r>
+            <a:r>
+              <a:rPr kumimoji="0" lang="fr-FR" sz="810" b="0" i="0" u="none" strike="noStrike" kern="1200" cap="none" spc="0" normalizeH="0" baseline="0" noProof="0" dirty="0">
+                <a:ln>
+                  <a:noFill/>
+                </a:ln>
+                <a:solidFill>
+                  <a:schemeClr val="bg1">
+                    <a:lumMod val="65000"/>
+                  </a:schemeClr>
+                </a:solidFill>
+                <a:effectLst/>
+                <a:uLnTx/>
+                <a:uFillTx/>
+                <a:latin typeface="Brown" pitchFamily="2" charset="77"/>
+                <a:ea typeface="+mn-ea"/>
+                <a:cs typeface="+mn-cs"/>
+              </a:rPr>
+              <a:t>.</a:t>
+            </a:r>
+            <a:endParaRPr kumimoji="0" lang="fr-FR" sz="810" b="1" i="0" u="none" strike="noStrike" kern="1200" cap="none" spc="0" normalizeH="0" baseline="0" noProof="0" dirty="0">
+              <a:ln>
+                <a:noFill/>
+              </a:ln>
+              <a:solidFill>
+                <a:schemeClr val="bg1">
+                  <a:lumMod val="65000"/>
+                </a:schemeClr>
+              </a:solidFill>
+              <a:effectLst/>
+              <a:uLnTx/>
+              <a:uFillTx/>
+              <a:latin typeface="Brown" pitchFamily="2" charset="77"/>
+              <a:ea typeface="+mn-ea"/>
+              <a:cs typeface="+mn-cs"/>
+            </a:endParaRPr>
+          </a:p>
+          <a:p>
+            <a:pPr algn="ctr"/>
+            <a:endParaRPr lang="fr-FR" sz="810" b="1" baseline="0" dirty="0">
+              <a:solidFill>
+                <a:schemeClr val="bg1">
+                  <a:lumMod val="65000"/>
+                </a:schemeClr>
+              </a:solidFill>
+              <a:latin typeface="Brown" pitchFamily="2" charset="77"/>
+            </a:endParaRPr>
+          </a:p>
+        </p:txBody>
+      </p:sp>
+    </p:spTree>
+    <p:extLst>
+      <p:ext uri="{BB962C8B-B14F-4D97-AF65-F5344CB8AC3E}">
+        <p14:creationId xmlns:p14="http://schemas.microsoft.com/office/powerpoint/2010/main" val="1024902377"/>
+      </p:ext>
+    </p:extLst>
+  </p:cSld>
+  <p:clrMapOvr>
+    <a:masterClrMapping/>
+  </p:clrMapOvr>
+  <mc:AlternateContent xmlns:mc="http://schemas.openxmlformats.org/markup-compatibility/2006" xmlns:p14="http://schemas.microsoft.com/office/powerpoint/2010/main">
+    <mc:Choice Requires="p14">
+      <p:transition spd="slow" p14:dur="1200">
+        <p14:prism dir="u"/>
+      </p:transition>
+    </mc:Choice>
+    <mc:Fallback xmlns="">
+      <p:transition spd="slow">
+        <p:fade/>
+      </p:transition>
+    </mc:Fallback>
+  </mc:AlternateContent>
+  <p:hf sldNum="0" hdr="0" ftr="0"/>
+</p:sldLayout>
+</file>
+
+<file path=ppt/slideLayouts/slideLayout20.xml><?xml version="1.0" encoding="utf-8"?>
 <p:sldLayout xmlns:a="http://schemas.openxmlformats.org/drawingml/2006/main" xmlns:r="http://schemas.openxmlformats.org/officeDocument/2006/relationships" xmlns:p="http://schemas.openxmlformats.org/presentationml/2006/main" preserve="1" userDrawn="1">
   <p:cSld name="Title and Content">
     <p:spTree>
@@ -9076,7 +8675,7 @@
 </p:sldLayout>
 </file>
 
-<file path=ppt/slideLayouts/slideLayout23.xml><?xml version="1.0" encoding="utf-8"?>
+<file path=ppt/slideLayouts/slideLayout21.xml><?xml version="1.0" encoding="utf-8"?>
 <p:sldLayout xmlns:a="http://schemas.openxmlformats.org/drawingml/2006/main" xmlns:r="http://schemas.openxmlformats.org/officeDocument/2006/relationships" xmlns:p="http://schemas.openxmlformats.org/presentationml/2006/main" preserve="1" userDrawn="1">
   <p:cSld name="Title Slide_2">
     <p:bg>
@@ -9159,7 +8758,7 @@
 </p:sldLayout>
 </file>
 
-<file path=ppt/slideLayouts/slideLayout24.xml><?xml version="1.0" encoding="utf-8"?>
+<file path=ppt/slideLayouts/slideLayout22.xml><?xml version="1.0" encoding="utf-8"?>
 <p:sldLayout xmlns:a="http://schemas.openxmlformats.org/drawingml/2006/main" xmlns:r="http://schemas.openxmlformats.org/officeDocument/2006/relationships" xmlns:p="http://schemas.openxmlformats.org/presentationml/2006/main" preserve="1" userDrawn="1">
   <p:cSld name="2_Title Only">
     <p:spTree>
@@ -9411,7 +9010,7 @@
 </p:sldLayout>
 </file>
 
-<file path=ppt/slideLayouts/slideLayout25.xml><?xml version="1.0" encoding="utf-8"?>
+<file path=ppt/slideLayouts/slideLayout23.xml><?xml version="1.0" encoding="utf-8"?>
 <p:sldLayout xmlns:a="http://schemas.openxmlformats.org/drawingml/2006/main" xmlns:r="http://schemas.openxmlformats.org/officeDocument/2006/relationships" xmlns:p="http://schemas.openxmlformats.org/presentationml/2006/main" userDrawn="1">
   <p:cSld name="2_タイトル スライド">
     <p:spTree>
@@ -9689,6 +9288,172 @@
 </p:sldLayout>
 </file>
 
+<file path=ppt/slideLayouts/slideLayout24.xml><?xml version="1.0" encoding="utf-8"?>
+<p:sldLayout xmlns:a="http://schemas.openxmlformats.org/drawingml/2006/main" xmlns:r="http://schemas.openxmlformats.org/officeDocument/2006/relationships" xmlns:p="http://schemas.openxmlformats.org/presentationml/2006/main" userDrawn="1">
+  <p:cSld name="3_Title Only">
+    <p:spTree>
+      <p:nvGrpSpPr>
+        <p:cNvPr id="1" name=""/>
+        <p:cNvGrpSpPr/>
+        <p:nvPr/>
+      </p:nvGrpSpPr>
+      <p:grpSpPr>
+        <a:xfrm>
+          <a:off x="0" y="0"/>
+          <a:ext cx="0" cy="0"/>
+          <a:chOff x="0" y="0"/>
+          <a:chExt cx="0" cy="0"/>
+        </a:xfrm>
+      </p:grpSpPr>
+      <p:sp>
+        <p:nvSpPr>
+          <p:cNvPr id="11" name="Rectangle 3"/>
+          <p:cNvSpPr>
+            <a:spLocks noGrp="1" noChangeArrowheads="1"/>
+          </p:cNvSpPr>
+          <p:nvPr>
+            <p:ph type="title"/>
+          </p:nvPr>
+        </p:nvSpPr>
+        <p:spPr bwMode="auto">
+          <a:xfrm>
+            <a:off x="125413" y="138113"/>
+            <a:ext cx="11000856" cy="406168"/>
+          </a:xfrm>
+          <a:prstGeom prst="rect">
+            <a:avLst/>
+          </a:prstGeom>
+          <a:noFill/>
+          <a:ln>
+            <a:noFill/>
+          </a:ln>
+          <a:effectLst/>
+        </p:spPr>
+        <p:txBody>
+          <a:bodyPr/>
+          <a:lstStyle>
+            <a:lvl1pPr>
+              <a:defRPr sz="1800" b="0">
+                <a:solidFill>
+                  <a:schemeClr val="tx1"/>
+                </a:solidFill>
+              </a:defRPr>
+            </a:lvl1pPr>
+          </a:lstStyle>
+          <a:p>
+            <a:pPr lvl="0"/>
+            <a:r>
+              <a:rPr lang="ja-JP" altLang="en-US"/>
+              <a:t>マスター タイトルの書式設定</a:t>
+            </a:r>
+            <a:endParaRPr lang="en-GB" dirty="0"/>
+          </a:p>
+        </p:txBody>
+      </p:sp>
+      <p:pic>
+        <p:nvPicPr>
+          <p:cNvPr id="2" name="Picture 2" descr="A red and black logo&#10;&#10;Description automatically generated">
+            <a:extLst>
+              <a:ext uri="{FF2B5EF4-FFF2-40B4-BE49-F238E27FC236}">
+                <a16:creationId xmlns:a16="http://schemas.microsoft.com/office/drawing/2014/main" id="{400EC8D7-6DC9-1605-F404-BE42B7E8F988}"/>
+              </a:ext>
+            </a:extLst>
+          </p:cNvPr>
+          <p:cNvPicPr>
+            <a:picLocks noChangeAspect="1"/>
+          </p:cNvPicPr>
+          <p:nvPr userDrawn="1"/>
+        </p:nvPicPr>
+        <p:blipFill>
+          <a:blip r:embed="rId2" cstate="screen">
+            <a:extLst>
+              <a:ext uri="{28A0092B-C50C-407E-A947-70E740481C1C}">
+                <a14:useLocalDpi xmlns:a14="http://schemas.microsoft.com/office/drawing/2010/main"/>
+              </a:ext>
+            </a:extLst>
+          </a:blip>
+          <a:stretch>
+            <a:fillRect/>
+          </a:stretch>
+        </p:blipFill>
+        <p:spPr>
+          <a:xfrm>
+            <a:off x="11182076" y="194549"/>
+            <a:ext cx="872930" cy="263759"/>
+          </a:xfrm>
+          <a:prstGeom prst="rect">
+            <a:avLst/>
+          </a:prstGeom>
+        </p:spPr>
+      </p:pic>
+      <p:sp>
+        <p:nvSpPr>
+          <p:cNvPr id="12" name="Text Placeholder 11">
+            <a:extLst>
+              <a:ext uri="{FF2B5EF4-FFF2-40B4-BE49-F238E27FC236}">
+                <a16:creationId xmlns:a16="http://schemas.microsoft.com/office/drawing/2014/main" id="{63AC8FD2-8097-2400-BA1E-5C2A5A1A5C2A}"/>
+              </a:ext>
+            </a:extLst>
+          </p:cNvPr>
+          <p:cNvSpPr>
+            <a:spLocks noGrp="1"/>
+          </p:cNvSpPr>
+          <p:nvPr>
+            <p:ph type="body" sz="quarter" idx="11" hasCustomPrompt="1"/>
+          </p:nvPr>
+        </p:nvSpPr>
+        <p:spPr>
+          <a:xfrm>
+            <a:off x="11046932" y="0"/>
+            <a:ext cx="1019656" cy="190053"/>
+          </a:xfrm>
+          <a:prstGeom prst="rect">
+            <a:avLst/>
+          </a:prstGeom>
+        </p:spPr>
+        <p:txBody>
+          <a:bodyPr/>
+          <a:lstStyle>
+            <a:lvl1pPr marL="0" indent="0" algn="r">
+              <a:buNone/>
+              <a:defRPr sz="800"/>
+            </a:lvl1pPr>
+            <a:lvl2pPr>
+              <a:defRPr sz="2000"/>
+            </a:lvl2pPr>
+            <a:lvl3pPr>
+              <a:defRPr sz="2000"/>
+            </a:lvl3pPr>
+            <a:lvl4pPr>
+              <a:defRPr sz="2000"/>
+            </a:lvl4pPr>
+            <a:lvl5pPr>
+              <a:defRPr sz="2000"/>
+            </a:lvl5pPr>
+          </a:lstStyle>
+          <a:p>
+            <a:pPr lvl="0"/>
+            <a:r>
+              <a:rPr lang="en-US" dirty="0"/>
+              <a:t>date/month/year</a:t>
+            </a:r>
+            <a:endParaRPr lang="en-FI" dirty="0"/>
+          </a:p>
+        </p:txBody>
+      </p:sp>
+    </p:spTree>
+    <p:extLst>
+      <p:ext uri="{BB962C8B-B14F-4D97-AF65-F5344CB8AC3E}">
+        <p14:creationId xmlns:p14="http://schemas.microsoft.com/office/powerpoint/2010/main" val="2916219519"/>
+      </p:ext>
+    </p:extLst>
+  </p:cSld>
+  <p:clrMapOvr>
+    <a:masterClrMapping/>
+  </p:clrMapOvr>
+</p:sldLayout>
+</file>
+
 <file path=ppt/slideLayouts/slideLayout3.xml><?xml version="1.0" encoding="utf-8"?>
 <p:sldLayout xmlns:a="http://schemas.openxmlformats.org/drawingml/2006/main" xmlns:r="http://schemas.openxmlformats.org/officeDocument/2006/relationships" xmlns:p="http://schemas.openxmlformats.org/presentationml/2006/main" preserve="1">
   <p:cSld name="4_Disposition personnalisée">
@@ -26409,14 +26174,13 @@
     <p:sldLayoutId id="2147483690" r:id="rId15"/>
     <p:sldLayoutId id="2147483691" r:id="rId16"/>
     <p:sldLayoutId id="2147483692" r:id="rId17"/>
-    <p:sldLayoutId id="2147483693" r:id="rId18"/>
-    <p:sldLayoutId id="2147483695" r:id="rId19"/>
-    <p:sldLayoutId id="2147483698" r:id="rId20"/>
-    <p:sldLayoutId id="2147483666" r:id="rId21"/>
-    <p:sldLayoutId id="2147483668" r:id="rId22"/>
-    <p:sldLayoutId id="2147483669" r:id="rId23"/>
-    <p:sldLayoutId id="2147483671" r:id="rId24"/>
-    <p:sldLayoutId id="2147483661" r:id="rId25"/>
+    <p:sldLayoutId id="2147483698" r:id="rId18"/>
+    <p:sldLayoutId id="2147483666" r:id="rId19"/>
+    <p:sldLayoutId id="2147483668" r:id="rId20"/>
+    <p:sldLayoutId id="2147483669" r:id="rId21"/>
+    <p:sldLayoutId id="2147483671" r:id="rId22"/>
+    <p:sldLayoutId id="2147483661" r:id="rId23"/>
+    <p:sldLayoutId id="2147483699" r:id="rId24"/>
   </p:sldLayoutIdLst>
   <mc:AlternateContent xmlns:mc="http://schemas.openxmlformats.org/markup-compatibility/2006" xmlns:p14="http://schemas.microsoft.com/office/powerpoint/2010/main">
     <mc:Choice Requires="p14">
@@ -26753,7 +26517,7 @@
         <p:cNvPr id="1" name="">
           <a:extLst>
             <a:ext uri="{FF2B5EF4-FFF2-40B4-BE49-F238E27FC236}">
-              <a16:creationId xmlns:a16="http://schemas.microsoft.com/office/drawing/2014/main" id="{F64B52A1-1847-60C7-2814-B29871D34349}"/>
+              <a16:creationId xmlns:a16="http://schemas.microsoft.com/office/drawing/2014/main" id="{B7ADF35D-6C93-7A53-C0F3-BCED39BA568A}"/>
             </a:ext>
           </a:extLst>
         </p:cNvPr>
@@ -26773,7 +26537,7 @@
           <p:cNvPr id="43" name="Titre 42">
             <a:extLst>
               <a:ext uri="{FF2B5EF4-FFF2-40B4-BE49-F238E27FC236}">
-                <a16:creationId xmlns:a16="http://schemas.microsoft.com/office/drawing/2014/main" id="{8FC9947F-171F-4F2E-6DA0-75EF81AD8AA8}"/>
+                <a16:creationId xmlns:a16="http://schemas.microsoft.com/office/drawing/2014/main" id="{8E6D659E-18E2-3D5A-7342-B804A978DAC1}"/>
               </a:ext>
             </a:extLst>
           </p:cNvPr>
@@ -26786,8 +26550,8 @@
         </p:nvSpPr>
         <p:spPr>
           <a:xfrm>
-            <a:off x="125413" y="394620"/>
-            <a:ext cx="11000856" cy="406168"/>
+            <a:off x="280657" y="627088"/>
+            <a:ext cx="10728960" cy="350000"/>
           </a:xfrm>
           <a:noFill/>
           <a:ln>
@@ -26797,7 +26561,7 @@
         </p:spPr>
         <p:txBody>
           <a:bodyPr vert="horz" lIns="91440" tIns="45720" rIns="91440" bIns="45720" rtlCol="0" anchor="ctr">
-            <a:normAutofit/>
+            <a:normAutofit fontScale="90000"/>
           </a:bodyPr>
           <a:lstStyle/>
           <a:p>
@@ -26806,7 +26570,7 @@
                 <a:latin typeface="+mn-lt"/>
                 <a:ea typeface="Meiryo UI" panose="020B0604030504040204" pitchFamily="50" charset="-128"/>
               </a:rPr>
-              <a:t>Aerodynamics in F1 | RacingNews365</a:t>
+              <a:t>Explained | The role of the wind tunnel in F1</a:t>
             </a:r>
             <a:endParaRPr lang="en-US" sz="2000" b="1" dirty="0">
               <a:latin typeface="+mn-lt"/>
@@ -26820,7 +26584,7 @@
           <p:cNvPr id="105" name="スライド番号プレースホルダー 5">
             <a:extLst>
               <a:ext uri="{FF2B5EF4-FFF2-40B4-BE49-F238E27FC236}">
-                <a16:creationId xmlns:a16="http://schemas.microsoft.com/office/drawing/2014/main" id="{E30C9293-54B9-A2E0-F1B0-E7229322AE28}"/>
+                <a16:creationId xmlns:a16="http://schemas.microsoft.com/office/drawing/2014/main" id="{09C7E34E-D997-6964-2F9D-B4F1424C521A}"/>
               </a:ext>
             </a:extLst>
           </p:cNvPr>
@@ -26950,7 +26714,7 @@
           <p:cNvPr id="107" name="Rectangle 1">
             <a:extLst>
               <a:ext uri="{FF2B5EF4-FFF2-40B4-BE49-F238E27FC236}">
-                <a16:creationId xmlns:a16="http://schemas.microsoft.com/office/drawing/2014/main" id="{063146B0-96B3-4AFD-5398-14E89C15081D}"/>
+                <a16:creationId xmlns:a16="http://schemas.microsoft.com/office/drawing/2014/main" id="{341C5790-F56F-BD66-D47C-55B5E7FF47F4}"/>
               </a:ext>
             </a:extLst>
           </p:cNvPr>
@@ -26961,8 +26725,8 @@
         </p:nvSpPr>
         <p:spPr bwMode="auto">
           <a:xfrm>
-            <a:off x="125413" y="0"/>
-            <a:ext cx="12192000" cy="0"/>
+            <a:off x="7832034" y="5946126"/>
+            <a:ext cx="1371600" cy="457200"/>
           </a:xfrm>
           <a:prstGeom prst="rect">
             <a:avLst/>
@@ -27085,7 +26849,7 @@
           <p:cNvPr id="108" name="Rectangle 2">
             <a:extLst>
               <a:ext uri="{FF2B5EF4-FFF2-40B4-BE49-F238E27FC236}">
-                <a16:creationId xmlns:a16="http://schemas.microsoft.com/office/drawing/2014/main" id="{84792874-7858-3F11-E4C9-CC2F8C5AC78E}"/>
+                <a16:creationId xmlns:a16="http://schemas.microsoft.com/office/drawing/2014/main" id="{6FEA7C6E-34DE-E587-74DD-FC45CB6159A2}"/>
               </a:ext>
             </a:extLst>
           </p:cNvPr>
@@ -27192,7 +26956,7 @@
           <p:cNvPr id="6" name="Rectangle 5">
             <a:extLst>
               <a:ext uri="{FF2B5EF4-FFF2-40B4-BE49-F238E27FC236}">
-                <a16:creationId xmlns:a16="http://schemas.microsoft.com/office/drawing/2014/main" id="{53B778B3-2B99-2774-5D76-2A2E6FDBF436}"/>
+                <a16:creationId xmlns:a16="http://schemas.microsoft.com/office/drawing/2014/main" id="{778F93DE-BE16-EC28-B975-8BE4F69C540B}"/>
               </a:ext>
             </a:extLst>
           </p:cNvPr>
@@ -27201,7 +26965,7 @@
         </p:nvSpPr>
         <p:spPr>
           <a:xfrm>
-            <a:off x="156190" y="87943"/>
+            <a:off x="390180" y="260059"/>
             <a:ext cx="2012011" cy="295960"/>
           </a:xfrm>
           <a:prstGeom prst="rect">
@@ -27243,7 +27007,7 @@
                   <a:srgbClr val="FF0000"/>
                 </a:solidFill>
               </a:rPr>
-              <a:t>GENERAL INNOVATION</a:t>
+              <a:t>TESTING &amp; SIMULATION</a:t>
             </a:r>
           </a:p>
         </p:txBody>
@@ -27253,7 +27017,7 @@
           <p:cNvPr id="8" name="Rectangle 7">
             <a:extLst>
               <a:ext uri="{FF2B5EF4-FFF2-40B4-BE49-F238E27FC236}">
-                <a16:creationId xmlns:a16="http://schemas.microsoft.com/office/drawing/2014/main" id="{DD4D3950-970B-89F8-C7A1-2967005DE240}"/>
+                <a16:creationId xmlns:a16="http://schemas.microsoft.com/office/drawing/2014/main" id="{AD48A0EC-74CE-3540-75F7-5FDCDC526BA0}"/>
               </a:ext>
             </a:extLst>
           </p:cNvPr>
@@ -27262,8 +27026,8 @@
         </p:nvSpPr>
         <p:spPr>
           <a:xfrm>
-            <a:off x="4837083" y="1260608"/>
-            <a:ext cx="1567207" cy="2168391"/>
+            <a:off x="4846320" y="1280160"/>
+            <a:ext cx="1542904" cy="2168391"/>
           </a:xfrm>
           <a:prstGeom prst="rect">
             <a:avLst/>
@@ -27355,7 +27119,7 @@
           <p:cNvPr id="9" name="Rectangle 8">
             <a:extLst>
               <a:ext uri="{FF2B5EF4-FFF2-40B4-BE49-F238E27FC236}">
-                <a16:creationId xmlns:a16="http://schemas.microsoft.com/office/drawing/2014/main" id="{697968AB-9661-ED3C-6D4B-302008F2DA7A}"/>
+                <a16:creationId xmlns:a16="http://schemas.microsoft.com/office/drawing/2014/main" id="{C3D20E17-256B-4082-7BAB-42B3CC873679}"/>
               </a:ext>
             </a:extLst>
           </p:cNvPr>
@@ -27364,8 +27128,8 @@
         </p:nvSpPr>
         <p:spPr>
           <a:xfrm>
-            <a:off x="4837083" y="3550098"/>
-            <a:ext cx="1567207" cy="2168391"/>
+            <a:off x="4846319" y="3613143"/>
+            <a:ext cx="1542905" cy="2168391"/>
           </a:xfrm>
           <a:prstGeom prst="rect">
             <a:avLst/>
@@ -27416,7 +27180,7 @@
           <p:cNvPr id="10" name="Rectangle 9">
             <a:extLst>
               <a:ext uri="{FF2B5EF4-FFF2-40B4-BE49-F238E27FC236}">
-                <a16:creationId xmlns:a16="http://schemas.microsoft.com/office/drawing/2014/main" id="{988D4CD6-9AE0-7B4C-FE17-A43CD14B4A8C}"/>
+                <a16:creationId xmlns:a16="http://schemas.microsoft.com/office/drawing/2014/main" id="{6D346B95-3C36-717D-2760-7C066CDBA825}"/>
               </a:ext>
             </a:extLst>
           </p:cNvPr>
@@ -27425,8 +27189,8 @@
         </p:nvSpPr>
         <p:spPr>
           <a:xfrm>
-            <a:off x="4837083" y="5839588"/>
-            <a:ext cx="1567207" cy="646718"/>
+            <a:off x="4846320" y="5946126"/>
+            <a:ext cx="1371600" cy="457200"/>
           </a:xfrm>
           <a:prstGeom prst="rect">
             <a:avLst/>
@@ -27477,7 +27241,7 @@
           <p:cNvPr id="11" name="Star: 5 Points 10">
             <a:extLst>
               <a:ext uri="{FF2B5EF4-FFF2-40B4-BE49-F238E27FC236}">
-                <a16:creationId xmlns:a16="http://schemas.microsoft.com/office/drawing/2014/main" id="{A5A52F69-2960-6E36-B13A-673F57665B07}"/>
+                <a16:creationId xmlns:a16="http://schemas.microsoft.com/office/drawing/2014/main" id="{F5715F23-F963-4E14-D0E8-ABE28CAF4C7D}"/>
               </a:ext>
             </a:extLst>
           </p:cNvPr>
@@ -27486,7 +27250,7 @@
         </p:nvSpPr>
         <p:spPr>
           <a:xfrm>
-            <a:off x="6838122" y="5987332"/>
+            <a:off x="6492240" y="6027627"/>
             <a:ext cx="294198" cy="294198"/>
           </a:xfrm>
           <a:prstGeom prst="star5">
@@ -27526,7 +27290,7 @@
           <p:cNvPr id="12" name="Star: 5 Points 11">
             <a:extLst>
               <a:ext uri="{FF2B5EF4-FFF2-40B4-BE49-F238E27FC236}">
-                <a16:creationId xmlns:a16="http://schemas.microsoft.com/office/drawing/2014/main" id="{6FB712B4-AE77-E34E-E5FF-AE2D79C8FF50}"/>
+                <a16:creationId xmlns:a16="http://schemas.microsoft.com/office/drawing/2014/main" id="{990A6B04-285D-8B04-F4E0-71C1CC2EE59D}"/>
               </a:ext>
             </a:extLst>
           </p:cNvPr>
@@ -27535,7 +27299,7 @@
         </p:nvSpPr>
         <p:spPr>
           <a:xfrm>
-            <a:off x="7222576" y="5987332"/>
+            <a:off x="6877878" y="6027627"/>
             <a:ext cx="294198" cy="294198"/>
           </a:xfrm>
           <a:prstGeom prst="star5">
@@ -27575,7 +27339,7 @@
           <p:cNvPr id="13" name="Star: 5 Points 12">
             <a:extLst>
               <a:ext uri="{FF2B5EF4-FFF2-40B4-BE49-F238E27FC236}">
-                <a16:creationId xmlns:a16="http://schemas.microsoft.com/office/drawing/2014/main" id="{D7701B1C-4EC7-A089-203D-09CE884AE876}"/>
+                <a16:creationId xmlns:a16="http://schemas.microsoft.com/office/drawing/2014/main" id="{2D00A79D-852A-B4D4-6285-76F1EE324FD3}"/>
               </a:ext>
             </a:extLst>
           </p:cNvPr>
@@ -27584,14 +27348,14 @@
         </p:nvSpPr>
         <p:spPr>
           <a:xfrm>
-            <a:off x="7607030" y="5987332"/>
+            <a:off x="7263516" y="6027627"/>
             <a:ext cx="294198" cy="294198"/>
           </a:xfrm>
           <a:prstGeom prst="star5">
             <a:avLst/>
           </a:prstGeom>
           <a:solidFill>
-            <a:srgbClr val="FFFFFF"/>
+            <a:srgbClr val="FFC000"/>
           </a:solidFill>
         </p:spPr>
         <p:style>
@@ -27624,7 +27388,7 @@
           <p:cNvPr id="14" name="Rectangle 13">
             <a:extLst>
               <a:ext uri="{FF2B5EF4-FFF2-40B4-BE49-F238E27FC236}">
-                <a16:creationId xmlns:a16="http://schemas.microsoft.com/office/drawing/2014/main" id="{2F43BD9D-8878-1774-AFE1-C01483395C66}"/>
+                <a16:creationId xmlns:a16="http://schemas.microsoft.com/office/drawing/2014/main" id="{5C16A441-4B9A-3277-8797-C1ED1A254A52}"/>
               </a:ext>
             </a:extLst>
           </p:cNvPr>
@@ -27633,8 +27397,8 @@
         </p:nvSpPr>
         <p:spPr>
           <a:xfrm>
-            <a:off x="6432218" y="1260608"/>
-            <a:ext cx="5319681" cy="2168391"/>
+            <a:off x="6628073" y="1266363"/>
+            <a:ext cx="5107887" cy="2168391"/>
           </a:xfrm>
           <a:prstGeom prst="rect">
             <a:avLst/>
@@ -27663,59 +27427,32 @@
           </a:fontRef>
         </p:style>
         <p:txBody>
-          <a:bodyPr rtlCol="0" anchor="t" anchorCtr="0">
-            <a:normAutofit/>
+          <a:bodyPr lIns="137160" tIns="91440" rIns="137160" bIns="91440" rtlCol="0" anchor="t" anchorCtr="0">
+            <a:normAutofit lnSpcReduction="10000"/>
           </a:bodyPr>
           <a:lstStyle/>
           <a:p>
             <a:pPr>
               <a:spcBef>
-                <a:spcPts val="600"/>
+                <a:spcPts val="400"/>
               </a:spcBef>
             </a:pPr>
             <a:r>
-              <a:rPr lang="en-US" sz="1400" dirty="0">
+              <a:rPr lang="en-US" sz="1200" dirty="0">
                 <a:solidFill>
                   <a:schemeClr val="tx1"/>
                 </a:solidFill>
               </a:rPr>
-              <a:t>Aerodynamics contribute to the design of an F1 car to reduce drag and generate downforce, which helps the car stick to the road better and go faster through. Aerodynamics contribute to the design of an F1 car to reduce drag and generate downforce, which helps the car stick to the road better and go faster through ...</a:t>
+              <a:t>The article titled "Explained | The role of the wind tunnel in F1" from the Aston Martin Aramco Formula One™ Team on YouTube likely delves into the critical function of wind tunnels in the development and performance optimization of Formula 1 cars. Given the snippet, it emphasizes the importance of wind tunnels as a vital tool for F1 teams, especially in the context of restricted track testing opportunities, which are limited to a few days each year. The content probably explores how wind tunnels are used to simulate and analyze aerodynamic properties, allowing teams to refine car designs and improve efficiency and speed. It may also discuss the technological innovations and methodologies employed within these facilities to gain competitive advantages. </a:t>
             </a:r>
           </a:p>
           <a:p>
             <a:pPr>
               <a:spcBef>
-                <a:spcPts val="600"/>
+                <a:spcPts val="400"/>
               </a:spcBef>
             </a:pPr>
-            <a:r>
-              <a:rPr lang="en-US" sz="1400" dirty="0">
-                <a:solidFill>
-                  <a:schemeClr val="tx1"/>
-                </a:solidFill>
-              </a:rPr>
-              <a:t>Aerodynamics contribute to the design of an F1 car to reduce drag and generate downforce, which helps the car stick to the road better and go faster through ...</a:t>
-            </a:r>
-          </a:p>
-          <a:p>
-            <a:pPr>
-              <a:spcBef>
-                <a:spcPts val="600"/>
-              </a:spcBef>
-            </a:pPr>
-            <a:endParaRPr lang="en-US" sz="1400" dirty="0">
-              <a:solidFill>
-                <a:schemeClr val="tx1"/>
-              </a:solidFill>
-            </a:endParaRPr>
-          </a:p>
-          <a:p>
-            <a:pPr>
-              <a:spcBef>
-                <a:spcPts val="600"/>
-              </a:spcBef>
-            </a:pPr>
-            <a:endParaRPr lang="en-US" sz="1400" dirty="0">
+            <a:endParaRPr lang="en-US" sz="1200" dirty="0">
               <a:solidFill>
                 <a:schemeClr val="tx1"/>
               </a:solidFill>
@@ -27728,7 +27465,7 @@
           <p:cNvPr id="15" name="ZoneTexte 4">
             <a:extLst>
               <a:ext uri="{FF2B5EF4-FFF2-40B4-BE49-F238E27FC236}">
-                <a16:creationId xmlns:a16="http://schemas.microsoft.com/office/drawing/2014/main" id="{7DDB1727-AC6C-35E1-3B82-57ACE8FD4C28}"/>
+                <a16:creationId xmlns:a16="http://schemas.microsoft.com/office/drawing/2014/main" id="{55A9F44B-2046-F475-8E63-A2531A7735A2}"/>
               </a:ext>
             </a:extLst>
           </p:cNvPr>
@@ -27737,8 +27474,8 @@
         </p:nvSpPr>
         <p:spPr>
           <a:xfrm>
-            <a:off x="6146" y="6618656"/>
-            <a:ext cx="8131896" cy="246221"/>
+            <a:off x="731520" y="6532298"/>
+            <a:ext cx="10728960" cy="400110"/>
           </a:xfrm>
           <a:prstGeom prst="rect">
             <a:avLst/>
@@ -27749,21 +27486,40 @@
           <a:bodyPr wrap="square">
             <a:spAutoFit/>
           </a:bodyPr>
-          <a:lstStyle/>
-          <a:p>
-            <a:r>
-              <a:rPr lang="fr-FR" sz="1000" b="0" i="0" strike="noStrike" dirty="0">
+          <a:lstStyle>
+            <a:defPPr>
+              <a:defRPr lang="ru-RU"/>
+            </a:defPPr>
+            <a:lvl1pPr>
+              <a:defRPr sz="1000">
                 <a:latin typeface="+mj-lt"/>
-              </a:rPr>
+              </a:defRPr>
+            </a:lvl1pPr>
+          </a:lstStyle>
+          <a:p>
+            <a:r>
+              <a:rPr lang="fr-FR" dirty="0"/>
               <a:t>Source: </a:t>
             </a:r>
             <a:r>
-              <a:rPr lang="fr-FR" sz="1000" b="0" i="0" strike="noStrike" dirty="0">
-                <a:latin typeface="+mj-lt"/>
+              <a:rPr lang="fr-FR" dirty="0">
                 <a:hlinkClick r:id="rId2"/>
               </a:rPr>
-              <a:t>https://racingnews365.com/aerodynamics-f1</a:t>
-            </a:r>
+              <a:t>https://www.youtube.com/</a:t>
+            </a:r>
+            <a:r>
+              <a:rPr lang="fr-FR" dirty="0"/>
+              <a:t> Date: </a:t>
+            </a:r>
+            <a:r>
+              <a:rPr lang="en-US" dirty="0"/>
+              <a:t>18/03/2026</a:t>
+            </a:r>
+          </a:p>
+          <a:p>
+            <a:endParaRPr lang="fr-FR" dirty="0">
+              <a:hlinkClick r:id="rId3"/>
+            </a:endParaRPr>
           </a:p>
         </p:txBody>
       </p:sp>
@@ -27772,7 +27528,7 @@
           <p:cNvPr id="17" name="Rectangle 16">
             <a:extLst>
               <a:ext uri="{FF2B5EF4-FFF2-40B4-BE49-F238E27FC236}">
-                <a16:creationId xmlns:a16="http://schemas.microsoft.com/office/drawing/2014/main" id="{5A82B850-8314-A4C4-EEA6-A342C34BF978}"/>
+                <a16:creationId xmlns:a16="http://schemas.microsoft.com/office/drawing/2014/main" id="{491AEC80-664C-8D44-0869-86FFAA93369D}"/>
               </a:ext>
             </a:extLst>
           </p:cNvPr>
@@ -27781,8 +27537,8 @@
         </p:nvSpPr>
         <p:spPr>
           <a:xfrm>
-            <a:off x="6432217" y="3561349"/>
-            <a:ext cx="5319681" cy="2168391"/>
+            <a:off x="6628074" y="3601377"/>
+            <a:ext cx="5107886" cy="2168391"/>
           </a:xfrm>
           <a:prstGeom prst="rect">
             <a:avLst/>
@@ -27811,56 +27567,36 @@
           </a:fontRef>
         </p:style>
         <p:txBody>
-          <a:bodyPr rtlCol="0" anchor="t" anchorCtr="0"/>
+          <a:bodyPr lIns="137160" tIns="91440" rIns="137160" bIns="91440" rtlCol="0" anchor="t" anchorCtr="0">
+            <a:normAutofit/>
+          </a:bodyPr>
           <a:lstStyle/>
           <a:p>
             <a:pPr>
               <a:spcBef>
-                <a:spcPts val="600"/>
+                <a:spcPts val="400"/>
               </a:spcBef>
             </a:pPr>
             <a:r>
-              <a:rPr lang="en-GB" sz="1400" dirty="0">
+              <a:rPr lang="en-GB" altLang="ja-JP" sz="1200" dirty="0">
                 <a:solidFill>
                   <a:schemeClr val="tx1"/>
                 </a:solidFill>
               </a:rPr>
-              <a:t>Mercedes' strong opposition to altering the 2026 engine regulations underscores potential instability in F1's technical direction.​</a:t>
-            </a:r>
-          </a:p>
-          <a:p>
-            <a:pPr marL="446088" lvl="1" indent="-271463">
+              <a:t>Placeholder text</a:t>
+            </a:r>
+          </a:p>
+          <a:p>
+            <a:pPr>
               <a:spcBef>
-                <a:spcPts val="600"/>
+                <a:spcPts val="400"/>
               </a:spcBef>
-              <a:buFont typeface="Wingdings" panose="05000000000000000000" pitchFamily="2" charset="2"/>
-              <a:buChar char="Ø"/>
             </a:pPr>
-            <a:r>
-              <a:rPr lang="en-GB" altLang="ja-JP" sz="1400" dirty="0">
-                <a:solidFill>
-                  <a:schemeClr val="tx1"/>
-                </a:solidFill>
-              </a:rPr>
-              <a:t>Such instability could deter OEMs seeking a predictable investment environment.​</a:t>
-            </a:r>
-          </a:p>
-          <a:p>
-            <a:pPr marL="446088" lvl="1" indent="-271463">
-              <a:spcBef>
-                <a:spcPts val="600"/>
-              </a:spcBef>
-              <a:buFont typeface="Wingdings" panose="05000000000000000000" pitchFamily="2" charset="2"/>
-              <a:buChar char="Ø"/>
-            </a:pPr>
-            <a:r>
-              <a:rPr lang="en-GB" altLang="ja-JP" sz="1400" dirty="0">
-                <a:solidFill>
-                  <a:schemeClr val="tx1"/>
-                </a:solidFill>
-              </a:rPr>
-              <a:t>Divergent views among teams on regulatory changes may signal a lack of consensus, increasing the risk for new entrants concerned about shifting competitive dynamics.</a:t>
-            </a:r>
+            <a:endParaRPr lang="en-GB" altLang="ja-JP" sz="1200" dirty="0">
+              <a:solidFill>
+                <a:schemeClr val="tx1"/>
+              </a:solidFill>
+            </a:endParaRPr>
           </a:p>
         </p:txBody>
       </p:sp>
@@ -27869,7 +27605,7 @@
           <p:cNvPr id="23" name="Star: 5 Points 22">
             <a:extLst>
               <a:ext uri="{FF2B5EF4-FFF2-40B4-BE49-F238E27FC236}">
-                <a16:creationId xmlns:a16="http://schemas.microsoft.com/office/drawing/2014/main" id="{AE0D7DE1-4799-4BB2-4289-1CF43F35CE90}"/>
+                <a16:creationId xmlns:a16="http://schemas.microsoft.com/office/drawing/2014/main" id="{0AA8F327-620E-5B33-507C-59D86452F855}"/>
               </a:ext>
             </a:extLst>
           </p:cNvPr>
@@ -27878,7 +27614,7 @@
         </p:nvSpPr>
         <p:spPr>
           <a:xfrm>
-            <a:off x="10408256" y="5987332"/>
+            <a:off x="9340794" y="6027627"/>
             <a:ext cx="294198" cy="294198"/>
           </a:xfrm>
           <a:prstGeom prst="star5">
@@ -27918,7 +27654,7 @@
           <p:cNvPr id="25" name="Star: 5 Points 24">
             <a:extLst>
               <a:ext uri="{FF2B5EF4-FFF2-40B4-BE49-F238E27FC236}">
-                <a16:creationId xmlns:a16="http://schemas.microsoft.com/office/drawing/2014/main" id="{59262AF6-4856-B08E-2B33-759E3D76EB4B}"/>
+                <a16:creationId xmlns:a16="http://schemas.microsoft.com/office/drawing/2014/main" id="{69E175BA-B5E9-11FB-98D0-E3B9858131CD}"/>
               </a:ext>
             </a:extLst>
           </p:cNvPr>
@@ -27927,7 +27663,7 @@
         </p:nvSpPr>
         <p:spPr>
           <a:xfrm>
-            <a:off x="10792710" y="5987332"/>
+            <a:off x="9726432" y="6027627"/>
             <a:ext cx="294198" cy="294198"/>
           </a:xfrm>
           <a:prstGeom prst="star5">
@@ -27967,7 +27703,7 @@
           <p:cNvPr id="26" name="Star: 5 Points 25">
             <a:extLst>
               <a:ext uri="{FF2B5EF4-FFF2-40B4-BE49-F238E27FC236}">
-                <a16:creationId xmlns:a16="http://schemas.microsoft.com/office/drawing/2014/main" id="{DCA99266-329E-7614-18F5-324664C0D3B5}"/>
+                <a16:creationId xmlns:a16="http://schemas.microsoft.com/office/drawing/2014/main" id="{B2770943-9DD7-926C-6ABD-ED3E2D1C620A}"/>
               </a:ext>
             </a:extLst>
           </p:cNvPr>
@@ -27976,14 +27712,14 @@
         </p:nvSpPr>
         <p:spPr>
           <a:xfrm>
-            <a:off x="11177164" y="5987332"/>
+            <a:off x="10112070" y="6027627"/>
             <a:ext cx="294198" cy="294198"/>
           </a:xfrm>
           <a:prstGeom prst="star5">
             <a:avLst/>
           </a:prstGeom>
           <a:solidFill>
-            <a:srgbClr val="FFFFFF"/>
+            <a:srgbClr val="FFC000"/>
           </a:solidFill>
         </p:spPr>
         <p:style>
@@ -28013,45 +27749,10 @@
       </p:sp>
       <p:sp>
         <p:nvSpPr>
-          <p:cNvPr id="7" name="ZoneTexte 6">
+          <p:cNvPr id="110" name="Rectangle 109">
             <a:extLst>
               <a:ext uri="{FF2B5EF4-FFF2-40B4-BE49-F238E27FC236}">
-                <a16:creationId xmlns:a16="http://schemas.microsoft.com/office/drawing/2014/main" id="{498E2E2C-8F31-E5FF-82E1-5816E08A47A1}"/>
-              </a:ext>
-            </a:extLst>
-          </p:cNvPr>
-          <p:cNvSpPr txBox="1"/>
-          <p:nvPr/>
-        </p:nvSpPr>
-        <p:spPr>
-          <a:xfrm>
-            <a:off x="156190" y="802333"/>
-            <a:ext cx="928459" cy="261610"/>
-          </a:xfrm>
-          <a:prstGeom prst="rect">
-            <a:avLst/>
-          </a:prstGeom>
-          <a:noFill/>
-        </p:spPr>
-        <p:txBody>
-          <a:bodyPr wrap="none" rtlCol="0">
-            <a:spAutoFit/>
-          </a:bodyPr>
-          <a:lstStyle/>
-          <a:p>
-            <a:r>
-              <a:rPr lang="en-US" sz="1100" dirty="0"/>
-              <a:t>15/03/2026</a:t>
-            </a:r>
-          </a:p>
-        </p:txBody>
-      </p:sp>
-      <p:sp>
-        <p:nvSpPr>
-          <p:cNvPr id="2" name="Rectangle 1">
-            <a:extLst>
-              <a:ext uri="{FF2B5EF4-FFF2-40B4-BE49-F238E27FC236}">
-                <a16:creationId xmlns:a16="http://schemas.microsoft.com/office/drawing/2014/main" id="{8363C82C-522F-B94D-384E-6370B9B0BACD}"/>
+                <a16:creationId xmlns:a16="http://schemas.microsoft.com/office/drawing/2014/main" id="{4F1CB5D0-4A21-35BA-E4C4-4D00B379E2FA}"/>
               </a:ext>
             </a:extLst>
           </p:cNvPr>
@@ -28060,8 +27761,88 @@
         </p:nvSpPr>
         <p:spPr>
           <a:xfrm>
-            <a:off x="8395841" y="5839588"/>
-            <a:ext cx="1567207" cy="646718"/>
+            <a:off x="4846320" y="3539991"/>
+            <a:ext cx="6614160" cy="9144"/>
+          </a:xfrm>
+          <a:prstGeom prst="rect">
+            <a:avLst/>
+          </a:prstGeom>
+          <a:solidFill>
+            <a:srgbClr val="C8C8C8"/>
+          </a:solidFill>
+          <a:ln>
+            <a:noFill/>
+          </a:ln>
+        </p:spPr>
+        <p:style>
+          <a:lnRef idx="1">
+            <a:schemeClr val="accent1"/>
+          </a:lnRef>
+          <a:fillRef idx="3">
+            <a:schemeClr val="accent1"/>
+          </a:fillRef>
+          <a:effectRef idx="2">
+            <a:schemeClr val="accent1"/>
+          </a:effectRef>
+          <a:fontRef idx="minor">
+            <a:schemeClr val="lt1"/>
+          </a:fontRef>
+        </p:style>
+        <p:txBody>
+          <a:bodyPr rtlCol="0" anchor="ctr"/>
+          <a:lstStyle/>
+          <a:p>
+            <a:pPr algn="ctr"/>
+            <a:endParaRPr/>
+          </a:p>
+        </p:txBody>
+      </p:sp>
+      <p:pic>
+        <p:nvPicPr>
+          <p:cNvPr id="112" name="Picture 111" descr="main.png">
+            <a:extLst>
+              <a:ext uri="{FF2B5EF4-FFF2-40B4-BE49-F238E27FC236}">
+                <a16:creationId xmlns:a16="http://schemas.microsoft.com/office/drawing/2014/main" id="{D93B911D-2C79-9B9A-9C90-62A76E760A45}"/>
+              </a:ext>
+            </a:extLst>
+          </p:cNvPr>
+          <p:cNvPicPr>
+            <a:picLocks noChangeAspect="1"/>
+          </p:cNvPicPr>
+          <p:nvPr/>
+        </p:nvPicPr>
+        <p:blipFill>
+          <a:blip r:embed="rId4"/>
+          <a:stretch>
+            <a:fillRect/>
+          </a:stretch>
+        </p:blipFill>
+        <p:spPr>
+          <a:xfrm>
+            <a:off x="781696" y="1389079"/>
+            <a:ext cx="3240989" cy="4501374"/>
+          </a:xfrm>
+          <a:prstGeom prst="rect">
+            <a:avLst/>
+          </a:prstGeom>
+        </p:spPr>
+      </p:pic>
+      <p:sp>
+        <p:nvSpPr>
+          <p:cNvPr id="4" name="Rectangle 3">
+            <a:extLst>
+              <a:ext uri="{FF2B5EF4-FFF2-40B4-BE49-F238E27FC236}">
+                <a16:creationId xmlns:a16="http://schemas.microsoft.com/office/drawing/2014/main" id="{E3A00D3A-AC3B-048E-FE98-1DA32431AA11}"/>
+              </a:ext>
+            </a:extLst>
+          </p:cNvPr>
+          <p:cNvSpPr/>
+          <p:nvPr/>
+        </p:nvSpPr>
+        <p:spPr>
+          <a:xfrm>
+            <a:off x="7740594" y="5939971"/>
+            <a:ext cx="1371600" cy="457200"/>
           </a:xfrm>
           <a:prstGeom prst="rect">
             <a:avLst/>
@@ -28107,46 +27888,10 @@
           </a:p>
         </p:txBody>
       </p:sp>
-      <p:pic>
-        <p:nvPicPr>
-          <p:cNvPr id="16" name="Picture 15">
-            <a:extLst>
-              <a:ext uri="{FF2B5EF4-FFF2-40B4-BE49-F238E27FC236}">
-                <a16:creationId xmlns:a16="http://schemas.microsoft.com/office/drawing/2014/main" id="{B42E6332-38FD-6185-06CF-A9B0297149FF}"/>
-              </a:ext>
-            </a:extLst>
-          </p:cNvPr>
-          <p:cNvPicPr>
-            <a:picLocks noChangeAspect="1"/>
-          </p:cNvPicPr>
-          <p:nvPr/>
-        </p:nvPicPr>
-        <p:blipFill>
-          <a:blip r:embed="rId3">
-            <a:extLst>
-              <a:ext uri="{28A0092B-C50C-407E-A947-70E740481C1C}">
-                <a14:useLocalDpi xmlns:a14="http://schemas.microsoft.com/office/drawing/2010/main" val="0"/>
-              </a:ext>
-            </a:extLst>
-          </a:blip>
-          <a:stretch>
-            <a:fillRect/>
-          </a:stretch>
-        </p:blipFill>
-        <p:spPr>
-          <a:xfrm>
-            <a:off x="250951" y="1749107"/>
-            <a:ext cx="4283778" cy="4068762"/>
-          </a:xfrm>
-          <a:prstGeom prst="rect">
-            <a:avLst/>
-          </a:prstGeom>
-        </p:spPr>
-      </p:pic>
     </p:spTree>
     <p:extLst>
       <p:ext uri="{BB962C8B-B14F-4D97-AF65-F5344CB8AC3E}">
-        <p14:creationId xmlns:p14="http://schemas.microsoft.com/office/powerpoint/2010/main" val="927885845"/>
+        <p14:creationId xmlns:p14="http://schemas.microsoft.com/office/powerpoint/2010/main" val="985086263"/>
       </p:ext>
     </p:extLst>
   </p:cSld>

</xml_diff>

<commit_message>
Map implications text to Client Relevance column, align credibility/relevance/stars to updated template
- Map Notion "Client Relevance" text column to implications field
- Widen credibility label (1.5" → 1.687") to align with labels above
- Update star positions and relevance box to match updated template

Co-Authored-By: Claude Opus 4.6 <noreply@anthropic.com>
</commit_message>
<xml_diff>
--- a/templates/slide_template.pptx
+++ b/templates/slide_template.pptx
@@ -26725,7 +26725,7 @@
         </p:nvSpPr>
         <p:spPr bwMode="auto">
           <a:xfrm>
-            <a:off x="7832034" y="5946126"/>
+            <a:off x="7967867" y="5925510"/>
             <a:ext cx="1371600" cy="457200"/>
           </a:xfrm>
           <a:prstGeom prst="rect">
@@ -27190,7 +27190,7 @@
         <p:spPr>
           <a:xfrm>
             <a:off x="4846320" y="5946126"/>
-            <a:ext cx="1371600" cy="457200"/>
+            <a:ext cx="1542904" cy="457200"/>
           </a:xfrm>
           <a:prstGeom prst="rect">
             <a:avLst/>
@@ -27250,7 +27250,7 @@
         </p:nvSpPr>
         <p:spPr>
           <a:xfrm>
-            <a:off x="6492240" y="6027627"/>
+            <a:off x="6628073" y="6007011"/>
             <a:ext cx="294198" cy="294198"/>
           </a:xfrm>
           <a:prstGeom prst="star5">
@@ -27299,7 +27299,7 @@
         </p:nvSpPr>
         <p:spPr>
           <a:xfrm>
-            <a:off x="6877878" y="6027627"/>
+            <a:off x="7013711" y="6007011"/>
             <a:ext cx="294198" cy="294198"/>
           </a:xfrm>
           <a:prstGeom prst="star5">
@@ -27348,7 +27348,7 @@
         </p:nvSpPr>
         <p:spPr>
           <a:xfrm>
-            <a:off x="7263516" y="6027627"/>
+            <a:off x="7399349" y="6007011"/>
             <a:ext cx="294198" cy="294198"/>
           </a:xfrm>
           <a:prstGeom prst="star5">
@@ -27614,7 +27614,7 @@
         </p:nvSpPr>
         <p:spPr>
           <a:xfrm>
-            <a:off x="9340794" y="6027627"/>
+            <a:off x="9476627" y="6007011"/>
             <a:ext cx="294198" cy="294198"/>
           </a:xfrm>
           <a:prstGeom prst="star5">
@@ -27663,7 +27663,7 @@
         </p:nvSpPr>
         <p:spPr>
           <a:xfrm>
-            <a:off x="9726432" y="6027627"/>
+            <a:off x="9862265" y="6007011"/>
             <a:ext cx="294198" cy="294198"/>
           </a:xfrm>
           <a:prstGeom prst="star5">
@@ -27712,7 +27712,7 @@
         </p:nvSpPr>
         <p:spPr>
           <a:xfrm>
-            <a:off x="10112070" y="6027627"/>
+            <a:off x="10247903" y="6007011"/>
             <a:ext cx="294198" cy="294198"/>
           </a:xfrm>
           <a:prstGeom prst="star5">
@@ -27841,7 +27841,7 @@
         </p:nvSpPr>
         <p:spPr>
           <a:xfrm>
-            <a:off x="7740594" y="5939971"/>
+            <a:off x="7876427" y="5919355"/>
             <a:ext cx="1371600" cy="457200"/>
           </a:xfrm>
           <a:prstGeom prst="rect">

</xml_diff>